<commit_message>
Conferencia: videos solo de 2025-2026 y lecturas centrales de 2024-2026
Reemplaza los cuatro videos de sala (2011-2023) por grabaciones recientes:
Uniandes 2026 (Desafíos del derecho en la era de la IA), Externado 2025
(fraude cibernético por servicios móviles; biometría y caso Mercado Libre
con la SIC) y Harvard 2026 (Petrie-Flom, Panel 4). Actualiza lecturas
obligatorias (The Practice 2026, Directrices UNESCO-Uniandes 2025, blogs
del Externado 2025-2026), rutas, nota metodológica, catálogo (184 fuentes
con marca de antigüedad) y diapositivas con los nuevos enlaces.

Co-Authored-By: Claude Fable 5.1 <noreply@anthropic.com>
Claude-Session: https://claude.ai/code/session_01UB1sG9zKZHSTbe4W1CPFGF
</commit_message>
<xml_diff>
--- a/conferencia-derecho-tecnologia/DIAPOSITIVAS.pptx
+++ b/conferencia-derecho-tecnologia/DIAPOSITIVAS.pptx
@@ -790,7 +790,7 @@
           <a:p>
             <a:r>
               <a:rPr lang="en-US" dirty="0"/>
-              <a:t>Fragmento de 6 min de la conferencia de Daniel Peña Valenzuela (Externado, 2018): contratos web click-wrap y browse-wrap y el salto al smart contract. Elegir el fragmento que contraste contrato web vs. smart contract; evitar la introducción. Puente de un minuto: la Ley 527 ya respondió validez, equivalentes funcionales y valor probatorio; lo nuevo es la ejecución automática e inmutable.</a:t>
+              <a:t>Fragmento de 6 min del webinar del Externado del 23 de julio de 2025 sobre medidas para mitigar el fraude cibernético por servicios móviles (grabación en la página Seminarios web 2025 y en la lista del Departamento en YouTube; copiar el enlace exacto al preparar la sesión). Elegir el fragmento sobre mecanismos de fraude y medidas de mitigación. Puente: todo lo que ocurre por WhatsApp, SMS o una app es un mensaje de datos; Ley 527 y art. 247 CGP. Plan B 2025: masterclass Compliance en entornos digitales, misma página.</a:t>
             </a:r>
             <a:endParaRPr lang="en-US" dirty="0"/>
           </a:p>
@@ -1318,7 +1318,7 @@
           <a:p>
             <a:r>
               <a:rPr lang="en-US" dirty="0"/>
-              <a:t>Fragmento de 5 min de la conferencia de Nelson Remolina Angarita (Uniandes, 4 Foro Cloud Computing): responsable-encargado y transferencia internacional; evitar la introducción. Luego 3 min con las cinco reglas: es la chuleta del Taller 2. Confirmar en fuente primaria el texto de la Circular Externa 002 de 2024 de la SIC y el listado vigente de países con nivel adecuado. Plan B: sesión de biometría de Seminarios web 2025 del Externado o Cuarta sesión de la Mesa Multiactor sobre Regulación de IA (Externado y Uniandes).</a:t>
+              <a:t>Fragmento de 5 min de Biometría bajo la lupa: el caso Mercado Libre y las nuevas reglas de juego (Externado, 3 de julio de 2025), con Carolina García Molina (SIC) y María del Pilar Cortés: elegir el segmento donde la SIC explica por qué el dato biométrico es sensible y por qué debe ofrecerse alternativa. Luego 3 min con las cinco reglas: chuleta del Taller 2. Plan B: un seminario web 2026 del Externado sobre IA y derechos digitales. Contexto Uniandes: XXV Jornadas GECTI (mayo de 2026). Confirmar en fuente primaria la Circular 002 de 2024 y el listado de países con nivel adecuado.</a:t>
             </a:r>
             <a:endParaRPr lang="en-US" dirty="0"/>
           </a:p>
@@ -1670,7 +1670,7 @@
           <a:p>
             <a:r>
               <a:rPr lang="en-US" dirty="0"/>
-              <a:t>Clip de 3 min de Jonathan Zittrain, Openness and Oversight of Artificial Intelligence (Harvard, 2017), subtitulado. Alternativa: (Deep) Learning From the Bench (Berkman Klein). Debate: 1 min de preparación por mesa, 1 min por posición, 1 de réplica. Posición modelo: la voz puede ser dato biométrico sensible; consentimiento escrito y específico, aviso de voz sintética, marca de agua o registro, prohibición de reutilización y entrenamiento, eliminación del modelo, protocolo ante suplantación (Ley 1273 de 2009 para el fraude). Segunda pregunta: la deuda intelectual de Zittrain no es argumento para prohibir sino para exigir explicabilidad proporcional, control humano y posibilidad de impugnar. Ejemplo colombiano listo: audio en proceso laboral cuestionado por posible deepfake; enlazar con el protocolo del Taller 1.</a:t>
+              <a:t>Clip de 3 min del Panel 4 de la Conferencia Anual 2026 del Petrie-Flom Center (Harvard Law School), segmento Algorithms That Choose Life: a True Lifecycle Approach for AI Governance, subtitulado. Alternativa 2026: AI Governance Speaker Series del Berkman Klein Center (Legal Telescopes, Neel Guha; Julie Brill). Debate: 1 min de preparación por mesa, 1 min por posición, 1 de réplica. Posición modelo: la voz puede ser dato biométrico sensible; consentimiento escrito y específico, aviso de voz sintética, marca de agua o registro, prohibición de reutilización y entrenamiento, eliminación del modelo, protocolo ante suplantación (Ley 1273 de 2009 para el fraude). Segunda pregunta: el daño algorítmico de Bar-Gill y Sunstein (2025) no es argumento para prohibir sino para exigir explicabilidad proporcional, control humano y posibilidad de impugnar. Ejemplo colombiano listo: audio en proceso laboral cuestionado por posible deepfake; enlazar con el protocolo del Taller 1.</a:t>
             </a:r>
             <a:endParaRPr lang="en-US" dirty="0"/>
           </a:p>
@@ -2286,7 +2286,7 @@
           <a:p>
             <a:r>
               <a:rPr lang="en-US" dirty="0"/>
-              <a:t>A mano alzada o con formulario por código QR. Anotar los porcentajes: se retoman en el cierre con la pregunta ¿alguien cambiaría hoy su respuesta? Cerrar con la idea de cibercompetencias (libro de Uniandes editado por María Lorena Flórez Rojas) y con el JOLT Primer: la IA ya ejecuta tareas jurídicas, pero la responsabilidad sigue siendo del abogado.</a:t>
+              <a:t>A mano alzada o con formulario por código QR. Anotar los porcentajes: se retoman en el cierre con la pregunta ¿alguien cambiaría hoy su respuesta? Cerrar con la idea de cibercompetencias (libro de Uniandes editado por María Lorena Flórez Rojas) y con la tesis de DeStefano en The Practice (Harvard, 2026): la IA es una máquina de respuestas, pero el valor del abogado nunca estuvo solo en la respuesta.</a:t>
             </a:r>
             <a:endParaRPr lang="en-US" dirty="0"/>
           </a:p>
@@ -2462,7 +2462,7 @@
           <a:p>
             <a:r>
               <a:rPr lang="en-US" dirty="0"/>
-              <a:t>Todos los enlaces se verificaron con búsquedas restringidas a los canales institucionales. Descargar los fragmentos con anticipación y marcar tiempos de inicio y fin; no navegar en vivo. La duración exacta de cada video se confirma al descargarlo.</a:t>
+              <a:t>Regla: en sala solo se proyectan grabaciones de 2025 y 2026. Los enlaces se verificaron con búsquedas restringidas a los canales institucionales; para los dos videos del Externado se verificó la página que recopila las grabaciones y hay que copiar el enlace exacto al preparar la sesión. Descargar los fragmentos con anticipación y marcar tiempos de inicio y fin; no navegar en vivo. La duración exacta de cada video se confirma al descargarlo.</a:t>
             </a:r>
             <a:endParaRPr lang="en-US" dirty="0"/>
           </a:p>
@@ -2550,7 +2550,7 @@
           <a:p>
             <a:r>
               <a:rPr lang="en-US" dirty="0"/>
-              <a:t>Fragmento de 4 a 5 minutos de Understanding Impacts of AI on the Legal Profession (CS50 for Lawyers, Harvard) con subtítulos en español. Descargado con marcas de tiempo; no navegar en vivo. Plan B en español: Desafíos del derecho en la era de la IA (Facultad de Derecho Uniandes, 2026). Recoger solo 2 o 3 respuestas en voz alta; sin debate.</a:t>
+              <a:t>Fragmento de 4 a 5 minutos de Desafíos del derecho en la era de la Inteligencia Artificial (Facultad de Derecho Uniandes, 6 de febrero de 2026). Descargado con marcas de tiempo; no navegar en vivo. Plan B: Retos de la IA en la protección de los derechos humanos (Uniandes, mayo de 2025). Alternativa en inglés: Sunstein, Imperfect Oracle (HLS Library, noviembre de 2025). Recoger solo 2 o 3 respuestas en voz alta; sin debate.</a:t>
             </a:r>
             <a:endParaRPr lang="en-US" dirty="0"/>
           </a:p>
@@ -5510,7 +5510,7 @@
                 <a:ea typeface="Cambria" pitchFamily="34" charset="-122"/>
                 <a:cs typeface="Cambria" pitchFamily="34" charset="-120"/>
               </a:rPr>
-              <a:t>Video 2 · Del contrato electrónico al smart contract</a:t>
+              <a:t>Video 2 · Fraude cibernético por canales móviles y prueba electrónica</a:t>
             </a:r>
             <a:endParaRPr lang="en-US" sz="2400" dirty="0"/>
           </a:p>
@@ -5769,7 +5769,7 @@
                 <a:ea typeface="Calibri" pitchFamily="34" charset="-122"/>
                 <a:cs typeface="Calibri" pitchFamily="34" charset="-120"/>
               </a:rPr>
-              <a:t>Del contrato electrónico a los smart contracts: perspectivas y prospectiva</a:t>
+              <a:t>Webinar: medidas para mitigar el fraude cibernético por medio de servicios móviles</a:t>
             </a:r>
             <a:endParaRPr lang="en-US" sz="1600" dirty="0"/>
           </a:p>
@@ -5808,7 +5808,7 @@
                 <a:ea typeface="Calibri" pitchFamily="34" charset="-122"/>
                 <a:cs typeface="Calibri" pitchFamily="34" charset="-120"/>
               </a:rPr>
-              <a:t>Daniel Peña Valenzuela · Universidad Externado de Colombia (2018)</a:t>
+              <a:t>Dpto. de Derecho, Comunicaciones y Tecnologías de la Información · Externado · 23 de julio de 2025</a:t>
             </a:r>
             <a:endParaRPr lang="en-US" sz="1150" dirty="0"/>
           </a:p>
@@ -5917,7 +5917,7 @@
                 <a:latin typeface="Calibri" pitchFamily="34" charset="0"/>
                 <a:ea typeface="Calibri" pitchFamily="34" charset="-122"/>
                 <a:cs typeface="Calibri" pitchFamily="34" charset="-120"/>
-                <a:hlinkClick r:id="rId2" invalidUrl="" action="" tgtFrame="" tooltip="https://www.youtube.com/watch?v=-ihaM9HKMvg" history="1" highlightClick="0" endSnd="0">
+                <a:hlinkClick r:id="rId2" invalidUrl="" action="" tgtFrame="" tooltip="https://www.uexternado.edu.co/derecho/departamento-derecho-las-telecomunicaciones-2/seminarios-web-2025/" history="1" highlightClick="0" endSnd="0">
                   <a:extLst>
                     <a:ext uri="{A12FA001-AC4F-418D-AE19-62706E023703}">
                       <ahyp:hlinkClr xmlns:ahyp="http://schemas.microsoft.com/office/drawing/2018/hyperlinkcolor" val="tx"/>
@@ -5925,7 +5925,7 @@
                   </a:extLst>
                 </a:hlinkClick>
               </a:rPr>
-              <a:t>▶  Abrir el video</a:t>
+              <a:t>▶  Abrir la grabación</a:t>
             </a:r>
             <a:endParaRPr lang="en-US" sz="1300" dirty="0"/>
           </a:p>
@@ -5968,7 +5968,7 @@
                 <a:latin typeface="Calibri" pitchFamily="34" charset="0"/>
                 <a:ea typeface="Calibri" pitchFamily="34" charset="-122"/>
                 <a:cs typeface="Calibri" pitchFamily="34" charset="-120"/>
-                <a:hlinkClick r:id="rId3" invalidUrl="" action="" tgtFrame="" tooltip="https://www.youtube.com/watch?v=-ihaM9HKMvg" history="1" highlightClick="0" endSnd="0">
+                <a:hlinkClick r:id="rId3" invalidUrl="" action="" tgtFrame="" tooltip="https://www.uexternado.edu.co/derecho/departamento-derecho-las-telecomunicaciones-2/seminarios-web-2025/" history="1" highlightClick="0" endSnd="0">
                   <a:extLst>
                     <a:ext uri="{A12FA001-AC4F-418D-AE19-62706E023703}">
                       <ahyp:hlinkClr xmlns:ahyp="http://schemas.microsoft.com/office/drawing/2018/hyperlinkcolor" val="tx"/>
@@ -5976,7 +5976,7 @@
                   </a:extLst>
                 </a:hlinkClick>
               </a:rPr>
-              <a:t>https://www.youtube.com/watch?v=-ihaM9HKMvg</a:t>
+              <a:t>uexternado.edu.co › Seminarios web 2025 (grabación)</a:t>
             </a:r>
             <a:endParaRPr lang="en-US" sz="950" dirty="0"/>
           </a:p>
@@ -5985,6 +5985,96 @@
       <p:sp>
         <p:nvSpPr>
           <p:cNvPr id="17" name="Text 13"/>
+          <p:cNvSpPr txBox="1"/>
+          <p:nvPr/>
+        </p:nvSpPr>
+        <p:spPr>
+          <a:xfrm>
+            <a:off x="777240" y="5486400"/>
+            <a:ext cx="4480560" cy="256032"/>
+          </a:xfrm>
+          <a:prstGeom prst="rect">
+            <a:avLst/>
+          </a:prstGeom>
+          <a:noFill/>
+          <a:ln/>
+        </p:spPr>
+        <p:txBody>
+          <a:bodyPr wrap="square" lIns="0" tIns="0" rIns="0" bIns="0" rtlCol="0" anchor="t"/>
+          <a:lstStyle/>
+          <a:p>
+            <a:pPr indent="0" marL="0">
+              <a:buNone/>
+            </a:pPr>
+            <a:r>
+              <a:rPr lang="en-US" sz="1050" i="1" dirty="0">
+                <a:solidFill>
+                  <a:srgbClr val="CADCFC"/>
+                </a:solidFill>
+                <a:latin typeface="Calibri" pitchFamily="34" charset="0"/>
+                <a:ea typeface="Calibri" pitchFamily="34" charset="-122"/>
+                <a:cs typeface="Calibri" pitchFamily="34" charset="-120"/>
+              </a:rPr>
+              <a:t>También en:</a:t>
+            </a:r>
+            <a:endParaRPr lang="en-US" sz="1050" dirty="0"/>
+          </a:p>
+        </p:txBody>
+      </p:sp>
+      <p:sp>
+        <p:nvSpPr>
+          <p:cNvPr id="18" name="Text 14"/>
+          <p:cNvSpPr txBox="1"/>
+          <p:nvPr/>
+        </p:nvSpPr>
+        <p:spPr>
+          <a:xfrm>
+            <a:off x="777240" y="5742432"/>
+            <a:ext cx="4480560" cy="457200"/>
+          </a:xfrm>
+          <a:prstGeom prst="rect">
+            <a:avLst/>
+          </a:prstGeom>
+          <a:noFill/>
+          <a:ln/>
+        </p:spPr>
+        <p:txBody>
+          <a:bodyPr wrap="square" lIns="0" tIns="0" rIns="0" bIns="0" rtlCol="0" anchor="t"/>
+          <a:lstStyle/>
+          <a:p>
+            <a:pPr algn="l" indent="0" marL="0">
+              <a:buNone/>
+            </a:pPr>
+            <a:r>
+              <a:rPr lang="en-US" sz="950" u="sng" dirty="0">
+                <a:solidFill>
+                  <a:srgbClr val="CADCFC"/>
+                </a:solidFill>
+                <a:uFill>
+                  <a:solidFill>
+                    <a:srgbClr val="CADCFC"/>
+                  </a:solidFill>
+                </a:uFill>
+                <a:latin typeface="Calibri" pitchFamily="34" charset="0"/>
+                <a:ea typeface="Calibri" pitchFamily="34" charset="-122"/>
+                <a:cs typeface="Calibri" pitchFamily="34" charset="-120"/>
+                <a:hlinkClick r:id="rId4" invalidUrl="" action="" tgtFrame="" tooltip="https://www.youtube.com/playlist?list=PLLdYhVJsMEXJsQw_DL_dNOejiIpp1OERr" history="1" highlightClick="0" endSnd="0">
+                  <a:extLst>
+                    <a:ext uri="{A12FA001-AC4F-418D-AE19-62706E023703}">
+                      <ahyp:hlinkClr xmlns:ahyp="http://schemas.microsoft.com/office/drawing/2018/hyperlinkcolor" val="tx"/>
+                    </a:ext>
+                  </a:extLst>
+                </a:hlinkClick>
+              </a:rPr>
+              <a:t>Lista del Departamento de Derecho, Comunicaciones y Tecnologías de la Información en YouTube (Externado)</a:t>
+            </a:r>
+            <a:endParaRPr lang="en-US" sz="950" dirty="0"/>
+          </a:p>
+        </p:txBody>
+      </p:sp>
+      <p:sp>
+        <p:nvSpPr>
+          <p:cNvPr id="19" name="Text 15"/>
           <p:cNvSpPr txBox="1"/>
           <p:nvPr/>
         </p:nvSpPr>
@@ -6023,7 +6113,7 @@
       </p:sp>
       <p:sp>
         <p:nvSpPr>
-          <p:cNvPr id="18" name="Shape 14"/>
+          <p:cNvPr id="20" name="Shape 16"/>
           <p:cNvSpPr/>
           <p:nvPr/>
         </p:nvSpPr>
@@ -6050,7 +6140,7 @@
       </p:sp>
       <p:sp>
         <p:nvSpPr>
-          <p:cNvPr id="19" name="Text 15"/>
+          <p:cNvPr id="21" name="Text 17"/>
           <p:cNvSpPr txBox="1"/>
           <p:nvPr/>
         </p:nvSpPr>
@@ -6089,7 +6179,7 @@
       </p:sp>
       <p:sp>
         <p:nvSpPr>
-          <p:cNvPr id="20" name="Text 16"/>
+          <p:cNvPr id="22" name="Text 18"/>
           <p:cNvSpPr txBox="1"/>
           <p:nvPr/>
         </p:nvSpPr>
@@ -6112,7 +6202,7 @@
               <a:buNone/>
             </a:pPr>
             <a:r>
-              <a:rPr lang="en-US" sz="1700" b="1" dirty="0">
+              <a:rPr lang="en-US" sz="1500" b="1" dirty="0">
                 <a:solidFill>
                   <a:srgbClr val="0F7C90"/>
                 </a:solidFill>
@@ -6120,15 +6210,15 @@
                 <a:ea typeface="Calibri" pitchFamily="34" charset="-122"/>
                 <a:cs typeface="Calibri" pitchFamily="34" charset="-120"/>
               </a:rPr>
-              <a:t>Abogado de la empresa</a:t>
-            </a:r>
-            <a:endParaRPr lang="en-US" sz="1700" dirty="0"/>
-          </a:p>
-        </p:txBody>
-      </p:sp>
-      <p:sp>
-        <p:nvSpPr>
-          <p:cNvPr id="21" name="Text 17"/>
+              <a:t>Abogado de la empresa víctima</a:t>
+            </a:r>
+            <a:endParaRPr lang="en-US" sz="1500" dirty="0"/>
+          </a:p>
+        </p:txBody>
+      </p:sp>
+      <p:sp>
+        <p:nvSpPr>
+          <p:cNvPr id="23" name="Text 19"/>
           <p:cNvSpPr txBox="1"/>
           <p:nvPr/>
         </p:nvSpPr>
@@ -6159,7 +6249,7 @@
                 <a:ea typeface="Calibri" pitchFamily="34" charset="-122"/>
                 <a:cs typeface="Calibri" pitchFamily="34" charset="-120"/>
               </a:rPr>
-              <a:t>¿Qué le conviene automatizar y qué riesgo asume?</a:t>
+              <a:t>¿Qué prueba necesita y cómo la asegura desde el primer día?</a:t>
             </a:r>
             <a:endParaRPr lang="en-US" sz="1200" dirty="0"/>
           </a:p>
@@ -6167,7 +6257,7 @@
       </p:sp>
       <p:sp>
         <p:nvSpPr>
-          <p:cNvPr id="22" name="Shape 18"/>
+          <p:cNvPr id="24" name="Shape 20"/>
           <p:cNvSpPr/>
           <p:nvPr/>
         </p:nvSpPr>
@@ -6194,7 +6284,7 @@
       </p:sp>
       <p:sp>
         <p:nvSpPr>
-          <p:cNvPr id="23" name="Text 19"/>
+          <p:cNvPr id="25" name="Text 21"/>
           <p:cNvSpPr txBox="1"/>
           <p:nvPr/>
         </p:nvSpPr>
@@ -6233,7 +6323,7 @@
       </p:sp>
       <p:sp>
         <p:nvSpPr>
-          <p:cNvPr id="24" name="Text 20"/>
+          <p:cNvPr id="26" name="Text 22"/>
           <p:cNvSpPr txBox="1"/>
           <p:nvPr/>
         </p:nvSpPr>
@@ -6256,7 +6346,7 @@
               <a:buNone/>
             </a:pPr>
             <a:r>
-              <a:rPr lang="en-US" sz="1700" b="1" dirty="0">
+              <a:rPr lang="en-US" sz="1500" b="1" dirty="0">
                 <a:solidFill>
                   <a:srgbClr val="E8A33D"/>
                 </a:solidFill>
@@ -6264,15 +6354,15 @@
                 <a:ea typeface="Calibri" pitchFamily="34" charset="-122"/>
                 <a:cs typeface="Calibri" pitchFamily="34" charset="-120"/>
               </a:rPr>
-              <a:t>Abogado del consumidor</a:t>
-            </a:r>
-            <a:endParaRPr lang="en-US" sz="1700" dirty="0"/>
-          </a:p>
-        </p:txBody>
-      </p:sp>
-      <p:sp>
-        <p:nvSpPr>
-          <p:cNvPr id="25" name="Text 21"/>
+              <a:t>Abogado del usuario</a:t>
+            </a:r>
+            <a:endParaRPr lang="en-US" sz="1500" dirty="0"/>
+          </a:p>
+        </p:txBody>
+      </p:sp>
+      <p:sp>
+        <p:nvSpPr>
+          <p:cNvPr id="27" name="Text 23"/>
           <p:cNvSpPr txBox="1"/>
           <p:nvPr/>
         </p:nvSpPr>
@@ -6303,7 +6393,7 @@
                 <a:ea typeface="Calibri" pitchFamily="34" charset="-122"/>
                 <a:cs typeface="Calibri" pitchFamily="34" charset="-120"/>
               </a:rPr>
-              <a:t>¿Dónde quedó el consentimiento y cómo se prueba?</a:t>
+              <a:t>¿Quién responde por la operación no autorizada y con qué evidencia?</a:t>
             </a:r>
             <a:endParaRPr lang="en-US" sz="1200" dirty="0"/>
           </a:p>
@@ -6311,7 +6401,7 @@
       </p:sp>
       <p:sp>
         <p:nvSpPr>
-          <p:cNvPr id="26" name="Shape 22"/>
+          <p:cNvPr id="28" name="Shape 24"/>
           <p:cNvSpPr/>
           <p:nvPr/>
         </p:nvSpPr>
@@ -6338,7 +6428,7 @@
       </p:sp>
       <p:sp>
         <p:nvSpPr>
-          <p:cNvPr id="27" name="Text 23"/>
+          <p:cNvPr id="29" name="Text 25"/>
           <p:cNvSpPr txBox="1"/>
           <p:nvPr/>
         </p:nvSpPr>
@@ -6377,7 +6467,7 @@
       </p:sp>
       <p:sp>
         <p:nvSpPr>
-          <p:cNvPr id="28" name="Text 24"/>
+          <p:cNvPr id="30" name="Text 26"/>
           <p:cNvSpPr txBox="1"/>
           <p:nvPr/>
         </p:nvSpPr>
@@ -6400,7 +6490,7 @@
               <a:buNone/>
             </a:pPr>
             <a:r>
-              <a:rPr lang="en-US" sz="1300" dirty="0">
+              <a:rPr lang="en-US" sz="1250" dirty="0">
                 <a:solidFill>
                   <a:srgbClr val="1F2937"/>
                 </a:solidFill>
@@ -6408,9 +6498,9 @@
                 <a:ea typeface="Calibri" pitchFamily="34" charset="-122"/>
                 <a:cs typeface="Calibri" pitchFamily="34" charset="-120"/>
               </a:rPr>
-              <a:t>La Ley 527 de 1999 ya respondió tres preguntas: validez del mensaje de datos, equivalentes funcionales y valor probatorio. Lo nuevo del smart contract es la ejecución automática e inmutable.</a:t>
-            </a:r>
-            <a:endParaRPr lang="en-US" sz="1300" dirty="0"/>
+              <a:t>Todo lo que ocurre por WhatsApp, SMS o una app es un mensaje de datos. La Ley 527 de 1999 ya respondió validez, equivalentes funcionales y valor probatorio; el art. 247 del CGP dice cómo se aporta. Lo nuevo es la velocidad del fraude y la ejecución automática de los contratos.</a:t>
+            </a:r>
+            <a:endParaRPr lang="en-US" sz="1250" dirty="0"/>
           </a:p>
         </p:txBody>
       </p:sp>
@@ -7888,7 +7978,7 @@
                 <a:ea typeface="Calibri" pitchFamily="34" charset="-122"/>
                 <a:cs typeface="Calibri" pitchFamily="34" charset="-120"/>
               </a:rPr>
-              <a:t>Memorias del I Foro «Ley 527 de 1999: dos décadas después» (Observatics, Externado; foro coorganizado con la Universidad de los Andes, 2019). Equivalencia funcional, firma electrónica y valor probatorio del mensaje de datos.</a:t>
+              <a:t>Doctrina de referencia (2019): Memorias del I Foro «Ley 527 de 1999: dos décadas después» (Observatics, Externado; foro coorganizado con la Universidad de los Andes). Equivalencia funcional, firma electrónica y valor probatorio del mensaje de datos.</a:t>
             </a:r>
             <a:endParaRPr lang="en-US" sz="1250" dirty="0"/>
           </a:p>
@@ -7993,7 +8083,7 @@
                 <a:ea typeface="Calibri" pitchFamily="34" charset="-122"/>
                 <a:cs typeface="Calibri" pitchFamily="34" charset="-120"/>
               </a:rPr>
-              <a:t>Jorge Padilla Sánchez, «Blockchain y contratos inteligentes: aproximación a sus problemáticas y retos jurídicos», Revista de Derecho Privado n.º 39 (Externado, 2020). Inmutabilidad, desintermediación y errores de programación irreversibles.</a:t>
+              <a:t>Doctrina de referencia (2020): Jorge Padilla Sánchez, «Blockchain y contratos inteligentes: aproximación a sus problemáticas y retos jurídicos», Revista de Derecho Privado n.º 39 (Externado). Inmutabilidad, desintermediación y errores irreversibles.</a:t>
             </a:r>
             <a:endParaRPr lang="en-US" sz="1250" dirty="0"/>
           </a:p>
@@ -10823,7 +10913,7 @@
                 <a:ea typeface="Cambria" pitchFamily="34" charset="-122"/>
                 <a:cs typeface="Cambria" pitchFamily="34" charset="-120"/>
               </a:rPr>
-              <a:t>Video 3 · Datos personales en la nube y en sistemas de IA</a:t>
+              <a:t>Video 3 · Biometría, datos sensibles y sistemas de IA</a:t>
             </a:r>
             <a:endParaRPr lang="en-US" sz="2400" dirty="0"/>
           </a:p>
@@ -11082,7 +11172,7 @@
                 <a:ea typeface="Calibri" pitchFamily="34" charset="-122"/>
                 <a:cs typeface="Calibri" pitchFamily="34" charset="-120"/>
               </a:rPr>
-              <a:t>Protección de datos personales · 4 Foro Cloud Computing (1/2)</a:t>
+              <a:t>Biometría bajo la lupa: el caso Mercado Libre y las nuevas reglas de juego</a:t>
             </a:r>
             <a:endParaRPr lang="en-US" sz="1600" dirty="0"/>
           </a:p>
@@ -11121,7 +11211,7 @@
                 <a:ea typeface="Calibri" pitchFamily="34" charset="-122"/>
                 <a:cs typeface="Calibri" pitchFamily="34" charset="-120"/>
               </a:rPr>
-              <a:t>Nelson Remolina Angarita · Universidad de los Andes (GECTI)</a:t>
+              <a:t>Con Carolina García Molina (SIC) y María del Pilar Cortés · Externado · 3 de julio de 2025</a:t>
             </a:r>
             <a:endParaRPr lang="en-US" sz="1150" dirty="0"/>
           </a:p>
@@ -11230,7 +11320,7 @@
                 <a:latin typeface="Calibri" pitchFamily="34" charset="0"/>
                 <a:ea typeface="Calibri" pitchFamily="34" charset="-122"/>
                 <a:cs typeface="Calibri" pitchFamily="34" charset="-120"/>
-                <a:hlinkClick r:id="rId2" invalidUrl="" action="" tgtFrame="" tooltip="https://www.youtube.com/watch?v=SSalLuF8SCw" history="1" highlightClick="0" endSnd="0">
+                <a:hlinkClick r:id="rId2" invalidUrl="" action="" tgtFrame="" tooltip="https://www.uexternado.edu.co/departamento-de-derecho-comunicaciones-y-tecnologias-de-la-informacion/biometria-bajo-la-lupa-el-caso-mercado-libre-y-las-nuevas-reglas-de-juego/" history="1" highlightClick="0" endSnd="0">
                   <a:extLst>
                     <a:ext uri="{A12FA001-AC4F-418D-AE19-62706E023703}">
                       <ahyp:hlinkClr xmlns:ahyp="http://schemas.microsoft.com/office/drawing/2018/hyperlinkcolor" val="tx"/>
@@ -11238,7 +11328,7 @@
                   </a:extLst>
                 </a:hlinkClick>
               </a:rPr>
-              <a:t>▶  Abrir el video</a:t>
+              <a:t>▶  Abrir la grabación</a:t>
             </a:r>
             <a:endParaRPr lang="en-US" sz="1300" dirty="0"/>
           </a:p>
@@ -11281,7 +11371,7 @@
                 <a:latin typeface="Calibri" pitchFamily="34" charset="0"/>
                 <a:ea typeface="Calibri" pitchFamily="34" charset="-122"/>
                 <a:cs typeface="Calibri" pitchFamily="34" charset="-120"/>
-                <a:hlinkClick r:id="rId3" invalidUrl="" action="" tgtFrame="" tooltip="https://www.youtube.com/watch?v=SSalLuF8SCw" history="1" highlightClick="0" endSnd="0">
+                <a:hlinkClick r:id="rId3" invalidUrl="" action="" tgtFrame="" tooltip="https://www.uexternado.edu.co/departamento-de-derecho-comunicaciones-y-tecnologias-de-la-informacion/biometria-bajo-la-lupa-el-caso-mercado-libre-y-las-nuevas-reglas-de-juego/" history="1" highlightClick="0" endSnd="0">
                   <a:extLst>
                     <a:ext uri="{A12FA001-AC4F-418D-AE19-62706E023703}">
                       <ahyp:hlinkClr xmlns:ahyp="http://schemas.microsoft.com/office/drawing/2018/hyperlinkcolor" val="tx"/>
@@ -11289,7 +11379,7 @@
                   </a:extLst>
                 </a:hlinkClick>
               </a:rPr>
-              <a:t>https://www.youtube.com/watch?v=SSalLuF8SCw</a:t>
+              <a:t>uexternado.edu.co › Biometría bajo la lupa (reseña y grabación)</a:t>
             </a:r>
             <a:endParaRPr lang="en-US" sz="950" dirty="0"/>
           </a:p>
@@ -11371,7 +11461,7 @@
                 <a:latin typeface="Calibri" pitchFamily="34" charset="0"/>
                 <a:ea typeface="Calibri" pitchFamily="34" charset="-122"/>
                 <a:cs typeface="Calibri" pitchFamily="34" charset="-120"/>
-                <a:hlinkClick r:id="rId4" invalidUrl="" action="" tgtFrame="" tooltip="https://www.uexternado.edu.co/derecho/departamento-derecho-las-telecomunicaciones-2/seminarios-web-2025/" history="1" highlightClick="0" endSnd="0">
+                <a:hlinkClick r:id="rId4" invalidUrl="" action="" tgtFrame="" tooltip="https://www.uexternado.edu.co/departamento-de-derecho-comunicaciones-y-tecnologias-de-la-informacion/seminarios-web-2026/" history="1" highlightClick="0" endSnd="0">
                   <a:extLst>
                     <a:ext uri="{A12FA001-AC4F-418D-AE19-62706E023703}">
                       <ahyp:hlinkClr xmlns:ahyp="http://schemas.microsoft.com/office/drawing/2018/hyperlinkcolor" val="tx"/>
@@ -11379,7 +11469,7 @@
                   </a:extLst>
                 </a:hlinkClick>
               </a:rPr>
-              <a:t>Seminarios web 2025 del Departamento de Derecho TIC (Externado): sesión de biometría</a:t>
+              <a:t>Seminarios web 2026 del Departamento de Derecho TIC (Externado): IA y derechos digitales</a:t>
             </a:r>
             <a:endParaRPr lang="en-US" sz="950" dirty="0"/>
           </a:p>
@@ -15646,7 +15736,7 @@
                 <a:ea typeface="Cambria" pitchFamily="34" charset="-122"/>
                 <a:cs typeface="Cambria" pitchFamily="34" charset="-120"/>
               </a:rPr>
-              <a:t>Video 4 y debate · Voz clonada y decisiones automatizadas</a:t>
+              <a:t>Video 4 y debate · Algoritmos que deciden y voces clonadas</a:t>
             </a:r>
             <a:endParaRPr lang="en-US" sz="2400" dirty="0"/>
           </a:p>
@@ -15905,7 +15995,7 @@
                 <a:ea typeface="Calibri" pitchFamily="34" charset="-122"/>
                 <a:cs typeface="Calibri" pitchFamily="34" charset="-120"/>
               </a:rPr>
-              <a:t>Openness and Oversight of Artificial Intelligence</a:t>
+              <a:t>Petrie-Flom Center 2026 Annual Conference · Panel 4: New Technology, New Challenges</a:t>
             </a:r>
             <a:endParaRPr lang="en-US" sz="1300" dirty="0"/>
           </a:p>
@@ -15944,7 +16034,7 @@
                 <a:ea typeface="Calibri" pitchFamily="34" charset="-122"/>
                 <a:cs typeface="Calibri" pitchFamily="34" charset="-120"/>
               </a:rPr>
-              <a:t>Jonathan Zittrain · Harvard Law School / Berkman Klein Center (2017) · clip de 3 min. Consigna: anote la afirmación con la que menos esté de acuerdo.</a:t>
+              <a:t>Harvard Law School, 2026 · clip de 3 min. Consigna: anote la afirmación con la que menos esté de acuerdo.</a:t>
             </a:r>
             <a:endParaRPr lang="en-US" sz="1050" dirty="0"/>
           </a:p>
@@ -16014,7 +16104,7 @@
                 <a:latin typeface="Calibri" pitchFamily="34" charset="0"/>
                 <a:ea typeface="Calibri" pitchFamily="34" charset="-122"/>
                 <a:cs typeface="Calibri" pitchFamily="34" charset="-120"/>
-                <a:hlinkClick r:id="rId2" invalidUrl="" action="" tgtFrame="" tooltip="https://www.youtube.com/watch?v=Jf5o1Dlv28w" history="1" highlightClick="0" endSnd="0">
+                <a:hlinkClick r:id="rId2" invalidUrl="" action="" tgtFrame="" tooltip="https://www.youtube.com/watch?v=2TEVQqAZpkg" history="1" highlightClick="0" endSnd="0">
                   <a:extLst>
                     <a:ext uri="{A12FA001-AC4F-418D-AE19-62706E023703}">
                       <ahyp:hlinkClr xmlns:ahyp="http://schemas.microsoft.com/office/drawing/2018/hyperlinkcolor" val="tx"/>
@@ -16065,7 +16155,7 @@
                 <a:latin typeface="Calibri" pitchFamily="34" charset="0"/>
                 <a:ea typeface="Calibri" pitchFamily="34" charset="-122"/>
                 <a:cs typeface="Calibri" pitchFamily="34" charset="-120"/>
-                <a:hlinkClick r:id="rId3" invalidUrl="" action="" tgtFrame="" tooltip="https://www.youtube.com/watch?v=Jf5o1Dlv28w" history="1" highlightClick="0" endSnd="0">
+                <a:hlinkClick r:id="rId3" invalidUrl="" action="" tgtFrame="" tooltip="https://www.youtube.com/watch?v=2TEVQqAZpkg" history="1" highlightClick="0" endSnd="0">
                   <a:extLst>
                     <a:ext uri="{A12FA001-AC4F-418D-AE19-62706E023703}">
                       <ahyp:hlinkClr xmlns:ahyp="http://schemas.microsoft.com/office/drawing/2018/hyperlinkcolor" val="tx"/>
@@ -16073,7 +16163,7 @@
                   </a:extLst>
                 </a:hlinkClick>
               </a:rPr>
-              <a:t>https://www.youtube.com/watch?v=Jf5o1Dlv28w</a:t>
+              <a:t>https://www.youtube.com/watch?v=2TEVQqAZpkg</a:t>
             </a:r>
             <a:endParaRPr lang="en-US" sz="950" dirty="0"/>
           </a:p>
@@ -16155,7 +16245,7 @@
                 <a:latin typeface="Calibri" pitchFamily="34" charset="0"/>
                 <a:ea typeface="Calibri" pitchFamily="34" charset="-122"/>
                 <a:cs typeface="Calibri" pitchFamily="34" charset="-120"/>
-                <a:hlinkClick r:id="rId4" invalidUrl="" action="" tgtFrame="" tooltip="https://www.youtube.com/watch?v=NlYjcldubBg" history="1" highlightClick="0" endSnd="0">
+                <a:hlinkClick r:id="rId4" invalidUrl="" action="" tgtFrame="" tooltip="https://www.youtube.com/playlist?list=PL68azUN8PTNg25bFCYPRWnNjILYoOrbtg" history="1" highlightClick="0" endSnd="0">
                   <a:extLst>
                     <a:ext uri="{A12FA001-AC4F-418D-AE19-62706E023703}">
                       <ahyp:hlinkClr xmlns:ahyp="http://schemas.microsoft.com/office/drawing/2018/hyperlinkcolor" val="tx"/>
@@ -16163,7 +16253,7 @@
                   </a:extLst>
                 </a:hlinkClick>
               </a:rPr>
-              <a:t>(Deep) Learning From the Bench (Berkman Klein)</a:t>
+              <a:t>AI Governance Speaker Series 2026 (Berkman Klein)</a:t>
             </a:r>
             <a:endParaRPr lang="en-US" sz="950" dirty="0"/>
           </a:p>
@@ -16515,7 +16605,7 @@
                 <a:ea typeface="Calibri" pitchFamily="34" charset="-122"/>
                 <a:cs typeface="Calibri" pitchFamily="34" charset="-120"/>
               </a:rPr>
-              <a:t>¿Qué riesgos jurídicos identifica y qué salvaguardas contractuales exigiría a un proveedor de clonación de voz? (caso Modulate, Berkman Klein)</a:t>
+              <a:t>¿Qué riesgos jurídicos identifica y qué salvaguardas contractuales exigiría a un proveedor de clonación de voz? (caso de estudio Modulate, Berkman Klein, 2020)</a:t>
             </a:r>
             <a:endParaRPr lang="en-US" sz="1250" dirty="0"/>
           </a:p>
@@ -16618,7 +16708,7 @@
                 <a:ea typeface="Calibri" pitchFamily="34" charset="-122"/>
                 <a:cs typeface="Calibri" pitchFamily="34" charset="-120"/>
               </a:rPr>
-              <a:t>¿La «deuda intelectual» de Zittrain es argumento para prohibir las decisiones automatizadas o para exigir explicabilidad? (nota de Uniandes sobre explicabilidad)</a:t>
+              <a:t>¿El «daño algorítmico» de Bar-Gill y Sunstein (Harvard, 2025) es argumento para prohibir las decisiones automatizadas o para exigir explicabilidad? (nota de Uniandes; Directrices UNESCO-Uniandes 2025)</a:t>
             </a:r>
             <a:endParaRPr lang="en-US" sz="1250" dirty="0"/>
           </a:p>
@@ -18668,7 +18758,7 @@
                 <a:ea typeface="Calibri" pitchFamily="34" charset="-122"/>
                 <a:cs typeface="Calibri" pitchFamily="34" charset="-120"/>
               </a:rPr>
-              <a:t>Especialización y Maestría en Derecho Informático y de las Nuevas Tecnologías</a:t>
+              <a:t>Ciclo de Conferencias 2026 (30 años del Dpto. de Derecho TIC) y Seminarios web 2025-2026</a:t>
             </a:r>
             <a:endParaRPr lang="en-US" sz="1200" dirty="0"/>
           </a:p>
@@ -18689,7 +18779,7 @@
                 <a:ea typeface="Calibri" pitchFamily="34" charset="-122"/>
                 <a:cs typeface="Calibri" pitchFamily="34" charset="-120"/>
               </a:rPr>
-              <a:t>Diplomado en Derecho, Regulación &amp; Tecnología</a:t>
+              <a:t>Relatorías 2025 de la Mesa Multiactor sobre Regulación de IA (con Uniandes); encuentro sobre gobernanza abierta de la IA (CONPES 4144)</a:t>
             </a:r>
             <a:endParaRPr lang="en-US" sz="1200" dirty="0"/>
           </a:p>
@@ -18710,7 +18800,7 @@
                 <a:ea typeface="Calibri" pitchFamily="34" charset="-122"/>
                 <a:cs typeface="Calibri" pitchFamily="34" charset="-120"/>
               </a:rPr>
-              <a:t>Curso de inmersión «IA para Abogados e Investigadores en Derecho»</a:t>
+              <a:t>Masterclass «El abogado como arquitecto de la gobernanza de la IA» (2026); Seminario de Actualización en Regulación de la IA (2026)</a:t>
             </a:r>
             <a:endParaRPr lang="en-US" sz="1200" dirty="0"/>
           </a:p>
@@ -18731,7 +18821,7 @@
                 <a:ea typeface="Calibri" pitchFamily="34" charset="-122"/>
                 <a:cs typeface="Calibri" pitchFamily="34" charset="-120"/>
               </a:rPr>
-              <a:t>Ciclo de Conferencias 2026 (30 años del Departamento de Derecho TIC) y Seminarios web</a:t>
+              <a:t>Curso de inmersión «IA para Abogados»; Especialización y Maestría en Derecho Informático</a:t>
             </a:r>
             <a:endParaRPr lang="en-US" sz="1200" dirty="0"/>
           </a:p>
@@ -18752,7 +18842,7 @@
                 <a:ea typeface="Calibri" pitchFamily="34" charset="-122"/>
                 <a:cs typeface="Calibri" pitchFamily="34" charset="-120"/>
               </a:rPr>
-              <a:t>Revista de Derecho Privado y Revista La Propiedad Inmaterial</a:t>
+              <a:t>Revista de Derecho Privado (Bertolini, 2025) y Derecho del Estado (Sanz Salguero, 2025)</a:t>
             </a:r>
             <a:endParaRPr lang="en-US" sz="1200" dirty="0"/>
           </a:p>
@@ -18888,7 +18978,7 @@
                 <a:ea typeface="Calibri" pitchFamily="34" charset="-122"/>
                 <a:cs typeface="Calibri" pitchFamily="34" charset="-120"/>
               </a:rPr>
-              <a:t>CS50's Computer Science for Lawyers (HarvardX, gratuito en auditoría)</a:t>
+              <a:t>Berkman Klein Center: AI Governance Speaker Series (2026) y Fall Speaker Series (2025)</a:t>
             </a:r>
             <a:endParaRPr lang="en-US" sz="1200" dirty="0"/>
           </a:p>
@@ -18909,7 +18999,7 @@
                 <a:ea typeface="Calibri" pitchFamily="34" charset="-122"/>
                 <a:cs typeface="Calibri" pitchFamily="34" charset="-120"/>
               </a:rPr>
-              <a:t>Berkman Klein Center: playlist Ethics &amp; Governance of AI; informe Principled AI</a:t>
+              <a:t>The Practice, «Adding Value in the Age of AI» (Center on the Legal Profession, 2026)</a:t>
             </a:r>
             <a:endParaRPr lang="en-US" sz="1200" dirty="0"/>
           </a:p>
@@ -18930,7 +19020,7 @@
                 <a:ea typeface="Calibri" pitchFamily="34" charset="-122"/>
                 <a:cs typeface="Calibri" pitchFamily="34" charset="-120"/>
               </a:rPr>
-              <a:t>Initiative on Artificial Intelligence and the Law (Bar-Gill y Sunstein)</a:t>
+              <a:t>Harvard Law Review, «Developments in the Law — Artificial Intelligence» (2025); Bar-Gill y Sunstein, «Algorithmic Harm» (2025)</a:t>
             </a:r>
             <a:endParaRPr lang="en-US" sz="1200" dirty="0"/>
           </a:p>
@@ -18951,7 +19041,7 @@
                 <a:ea typeface="Calibri" pitchFamily="34" charset="-122"/>
                 <a:cs typeface="Calibri" pitchFamily="34" charset="-120"/>
               </a:rPr>
-              <a:t>The Practice: «Generative AI in the Legal Profession» (2023)</a:t>
+              <a:t>Programa ejecutivo «AI and the Law: Navigating the New Legal Landscape» (edición 2026)</a:t>
             </a:r>
             <a:endParaRPr lang="en-US" sz="1200" dirty="0"/>
           </a:p>
@@ -18972,7 +19062,7 @@
                 <a:ea typeface="Calibri" pitchFamily="34" charset="-122"/>
                 <a:cs typeface="Calibri" pitchFamily="34" charset="-120"/>
               </a:rPr>
-              <a:t>Harvard Journal of Law &amp; Technology, vol. 38: Sobel y Bracha sobre IA generativa y derecho de autor</a:t>
+              <a:t>Initiative on Artificial Intelligence and the Law (Bar-Gill y Sunstein)</a:t>
             </a:r>
             <a:endParaRPr lang="en-US" sz="1200" dirty="0"/>
           </a:p>
@@ -19108,7 +19198,7 @@
                 <a:ea typeface="Calibri" pitchFamily="34" charset="-122"/>
                 <a:cs typeface="Calibri" pitchFamily="34" charset="-120"/>
               </a:rPr>
-              <a:t>Observatorio Ciro Angarita Barón: jurisprudencia de habeas data y Guía GECTI</a:t>
+              <a:t>Maestría en Derecho, Tecnología y Sociedad Digital; curso «Protección de Datos y Accountability» (GECTI)</a:t>
             </a:r>
             <a:endParaRPr lang="en-US" sz="1200" dirty="0"/>
           </a:p>
@@ -19129,7 +19219,7 @@
                 <a:ea typeface="Calibri" pitchFamily="34" charset="-122"/>
                 <a:cs typeface="Calibri" pitchFamily="34" charset="-120"/>
               </a:rPr>
-              <a:t>Toolkit ético legal de IA y semillero Lab IA/Law</a:t>
+              <a:t>Uniandes Legal Fest 2026 y XXV Jornadas GECTI (mayo de 2026)</a:t>
             </a:r>
             <a:endParaRPr lang="en-US" sz="1200" dirty="0"/>
           </a:p>
@@ -19150,7 +19240,7 @@
                 <a:ea typeface="Calibri" pitchFamily="34" charset="-122"/>
                 <a:cs typeface="Calibri" pitchFamily="34" charset="-120"/>
               </a:rPr>
-              <a:t>Maestría en Derecho, Tecnología y Sociedad Digital</a:t>
+              <a:t>Directrices UNESCO para el uso de IA en cortes y tribunales, versión en español (Escuela de Gobierno, 2025)</a:t>
             </a:r>
             <a:endParaRPr lang="en-US" sz="1200" dirty="0"/>
           </a:p>
@@ -19171,7 +19261,7 @@
                 <a:ea typeface="Calibri" pitchFamily="34" charset="-122"/>
                 <a:cs typeface="Calibri" pitchFamily="34" charset="-120"/>
               </a:rPr>
-              <a:t>Curso de Educación Continua «Protección de Datos y Accountability» (GECTI)</a:t>
+              <a:t>Toolkit ético legal de IA y semillero Lab IA/Law</a:t>
             </a:r>
             <a:endParaRPr lang="en-US" sz="1200" dirty="0"/>
           </a:p>
@@ -19192,7 +19282,7 @@
                 <a:ea typeface="Calibri" pitchFamily="34" charset="-122"/>
                 <a:cs typeface="Calibri" pitchFamily="34" charset="-120"/>
               </a:rPr>
-              <a:t>Coursera: «Introducción a la inteligencia artificial contemporánea» (en español)</a:t>
+              <a:t>Observatorio Ciro Angarita Barón: jurisprudencia de habeas data</a:t>
             </a:r>
             <a:endParaRPr lang="en-US" sz="1200" dirty="0"/>
           </a:p>
@@ -19396,7 +19486,7 @@
                   </a:extLst>
                 </a:hlinkClick>
               </a:rPr>
-              <a:t>Resumen de la Sentencia T-323 de 2024 (Blog del Dpto. de Propiedad Intelectual)</a:t>
+              <a:t>Resumen de la Sentencia T-323 de 2024 (Blog del Dpto. de Propiedad Intelectual, 2024)</a:t>
             </a:r>
             <a:endParaRPr lang="en-US" sz="1050" dirty="0"/>
           </a:p>
@@ -19421,7 +19511,7 @@
                 <a:latin typeface="Calibri" pitchFamily="34" charset="0"/>
                 <a:ea typeface="Calibri" pitchFamily="34" charset="-122"/>
                 <a:cs typeface="Calibri" pitchFamily="34" charset="-120"/>
-                <a:hlinkClick r:id="rId2" invalidUrl="" action="" tgtFrame="" tooltip="https://www.uexternado.edu.co/wp-content/uploads/2025/06/RELATORIA-Analisis-de-la-sentencia-T-323-Corte-Constitucional_27-de-AGO-2024.pdf" history="1" highlightClick="0" endSnd="0">
+                <a:hlinkClick r:id="rId2" invalidUrl="" action="" tgtFrame="" tooltip="https://telecomunicaciones.uexternado.edu.co/cuando-la-inteligencia-artificial-inventa-el-derecho-riesgos-para-la-profesion-juridica/" history="1" highlightClick="0" endSnd="0">
                   <a:extLst>
                     <a:ext uri="{A12FA001-AC4F-418D-AE19-62706E023703}">
                       <ahyp:hlinkClr xmlns:ahyp="http://schemas.microsoft.com/office/drawing/2018/hyperlinkcolor" val="tx"/>
@@ -19429,7 +19519,7 @@
                   </a:extLst>
                 </a:hlinkClick>
               </a:rPr>
-              <a:t>Relatoría del conversatorio sobre la T-323 de 2024 (PDF)</a:t>
+              <a:t>Cuando la inteligencia artificial inventa el derecho: riesgos para la profesión jurídica (2025)</a:t>
             </a:r>
             <a:endParaRPr lang="en-US" sz="1050" dirty="0"/>
           </a:p>
@@ -19462,7 +19552,7 @@
                   </a:extLst>
                 </a:hlinkClick>
               </a:rPr>
-              <a:t>El Externado analiza el uso de la IA en la justicia colombiana (STC17832-2025 y AC739-2026)</a:t>
+              <a:t>El Externado analiza el uso de la IA en la justicia colombiana: STC17832-2025 y AC739-2026 (2026)</a:t>
             </a:r>
             <a:endParaRPr lang="en-US" sz="1050" dirty="0"/>
           </a:p>
@@ -19487,7 +19577,7 @@
                 <a:latin typeface="Calibri" pitchFamily="34" charset="0"/>
                 <a:ea typeface="Calibri" pitchFamily="34" charset="-122"/>
                 <a:cs typeface="Calibri" pitchFamily="34" charset="-120"/>
-                <a:hlinkClick r:id="rId4" invalidUrl="" action="" tgtFrame="" tooltip="https://observatics.uexternado.edu.co/memorias-i-foro-ley-527-de-1999-dos-decadas-despues/" history="1" highlightClick="0" endSnd="0">
+                <a:hlinkClick r:id="rId4" invalidUrl="" action="" tgtFrame="" tooltip="https://www.uexternado.edu.co/derecho/departamento-derecho-las-telecomunicaciones-2/seminarios-web-2025/" history="1" highlightClick="0" endSnd="0">
                   <a:extLst>
                     <a:ext uri="{A12FA001-AC4F-418D-AE19-62706E023703}">
                       <ahyp:hlinkClr xmlns:ahyp="http://schemas.microsoft.com/office/drawing/2018/hyperlinkcolor" val="tx"/>
@@ -19495,7 +19585,7 @@
                   </a:extLst>
                 </a:hlinkClick>
               </a:rPr>
-              <a:t>Memorias I Foro Ley 527 de 1999: dos décadas después (Observatics)</a:t>
+              <a:t>Seminarios web 2025: fraude cibernético por servicios móviles; compliance digital; biometría (2025)</a:t>
             </a:r>
             <a:endParaRPr lang="en-US" sz="1050" dirty="0"/>
           </a:p>
@@ -19520,7 +19610,7 @@
                 <a:latin typeface="Calibri" pitchFamily="34" charset="0"/>
                 <a:ea typeface="Calibri" pitchFamily="34" charset="-122"/>
                 <a:cs typeface="Calibri" pitchFamily="34" charset="-120"/>
-                <a:hlinkClick r:id="rId5" invalidUrl="" action="" tgtFrame="" tooltip="https://revistas.uexternado.edu.co/index.php/derpri/article/view/6681" history="1" highlightClick="0" endSnd="0">
+                <a:hlinkClick r:id="rId5" invalidUrl="" action="" tgtFrame="" tooltip="https://www.uexternado.edu.co/departamento-de-derecho-comunicaciones-y-tecnologias-de-la-informacion/biometria-bajo-la-lupa-el-caso-mercado-libre-y-las-nuevas-reglas-de-juego/" history="1" highlightClick="0" endSnd="0">
                   <a:extLst>
                     <a:ext uri="{A12FA001-AC4F-418D-AE19-62706E023703}">
                       <ahyp:hlinkClr xmlns:ahyp="http://schemas.microsoft.com/office/drawing/2018/hyperlinkcolor" val="tx"/>
@@ -19528,7 +19618,7 @@
                   </a:extLst>
                 </a:hlinkClick>
               </a:rPr>
-              <a:t>Padilla Sánchez, Blockchain y contratos inteligentes (Rev. Derecho Privado n.º 39)</a:t>
+              <a:t>Biometría bajo la lupa: el caso Mercado Libre y las nuevas reglas de juego (2025)</a:t>
             </a:r>
             <a:endParaRPr lang="en-US" sz="1050" dirty="0"/>
           </a:p>
@@ -19553,7 +19643,7 @@
                 <a:latin typeface="Calibri" pitchFamily="34" charset="0"/>
                 <a:ea typeface="Calibri" pitchFamily="34" charset="-122"/>
                 <a:cs typeface="Calibri" pitchFamily="34" charset="-120"/>
-                <a:hlinkClick r:id="rId6" invalidUrl="" action="" tgtFrame="" tooltip="https://revistas.uexternado.edu.co/index.php/derpri/article/view/6298" history="1" highlightClick="0" endSnd="0">
+                <a:hlinkClick r:id="rId6" invalidUrl="" action="" tgtFrame="" tooltip="https://www.uexternado.edu.co/departamento-de-derecho-comunicaciones-y-tecnologias-de-la-informacion/relatorias-2025/" history="1" highlightClick="0" endSnd="0">
                   <a:extLst>
                     <a:ext uri="{A12FA001-AC4F-418D-AE19-62706E023703}">
                       <ahyp:hlinkClr xmlns:ahyp="http://schemas.microsoft.com/office/drawing/2018/hyperlinkcolor" val="tx"/>
@@ -19561,7 +19651,7 @@
                   </a:extLst>
                 </a:hlinkClick>
               </a:rPr>
-              <a:t>Almonacid y Coronel, IA y blockchain en el derecho contractual (Rev. Derecho Privado n.º 38)</a:t>
+              <a:t>Relatorías 2025 de la Mesa de Trabajo Multiactor sobre Regulación de IA (con Uniandes)</a:t>
             </a:r>
             <a:endParaRPr lang="en-US" sz="1050" dirty="0"/>
           </a:p>
@@ -19586,7 +19676,7 @@
                 <a:latin typeface="Calibri" pitchFamily="34" charset="0"/>
                 <a:ea typeface="Calibri" pitchFamily="34" charset="-122"/>
                 <a:cs typeface="Calibri" pitchFamily="34" charset="-120"/>
-                <a:hlinkClick r:id="rId7" invalidUrl="" action="" tgtFrame="" tooltip="https://www.uexternado.edu.co/departamento-de-derecho-comunicaciones-y-tecnologias-de-la-informacion/biometria-bajo-la-lupa-el-caso-mercado-libre-y-las-nuevas-reglas-de-juego/" history="1" highlightClick="0" endSnd="0">
+                <a:hlinkClick r:id="rId7" invalidUrl="" action="" tgtFrame="" tooltip="https://www.uexternado.edu.co/wp-content/uploads/2025/08/RELATORIA_%E2%80%98Privacidad-Proteccion-De-Datos-A-Proposito-Del-Caso-Studio-Ghibli_-30-ABR-2025.pdf" history="1" highlightClick="0" endSnd="0">
                   <a:extLst>
                     <a:ext uri="{A12FA001-AC4F-418D-AE19-62706E023703}">
                       <ahyp:hlinkClr xmlns:ahyp="http://schemas.microsoft.com/office/drawing/2018/hyperlinkcolor" val="tx"/>
@@ -19594,7 +19684,7 @@
                   </a:extLst>
                 </a:hlinkClick>
               </a:rPr>
-              <a:t>Biometría bajo la lupa: el caso Mercado Libre</a:t>
+              <a:t>Relatoría «Privacidad y protección de datos: a propósito del caso Studio Ghibli» (2025)</a:t>
             </a:r>
             <a:endParaRPr lang="en-US" sz="1050" dirty="0"/>
           </a:p>
@@ -19619,7 +19709,7 @@
                 <a:latin typeface="Calibri" pitchFamily="34" charset="0"/>
                 <a:ea typeface="Calibri" pitchFamily="34" charset="-122"/>
                 <a:cs typeface="Calibri" pitchFamily="34" charset="-120"/>
-                <a:hlinkClick r:id="rId8" invalidUrl="" action="" tgtFrame="" tooltip="https://www.uexternado.edu.co/evento/departamento-de-derecho-comunicaciones-y-tecnologias-de-la-informacion/conversatorio-el-tratamiento-de-datos-personales-en-sistemas-de-inteligencia-artificial/" history="1" highlightClick="0" endSnd="0">
+                <a:hlinkClick r:id="rId8" invalidUrl="" action="" tgtFrame="" tooltip="https://revistas.uexternado.edu.co/index.php/derpri/article/view/6681" history="1" highlightClick="0" endSnd="0">
                   <a:extLst>
                     <a:ext uri="{A12FA001-AC4F-418D-AE19-62706E023703}">
                       <ahyp:hlinkClr xmlns:ahyp="http://schemas.microsoft.com/office/drawing/2018/hyperlinkcolor" val="tx"/>
@@ -19627,7 +19717,7 @@
                   </a:extLst>
                 </a:hlinkClick>
               </a:rPr>
-              <a:t>Conversatorio: datos personales en sistemas de IA (Circular 002 de 2024, SIC)</a:t>
+              <a:t>Padilla Sánchez, Blockchain y contratos inteligentes (Rev. Derecho Privado, 2020; doctrina de referencia)</a:t>
             </a:r>
             <a:endParaRPr lang="en-US" sz="1050" dirty="0"/>
           </a:p>
@@ -19713,7 +19803,7 @@
                 <a:latin typeface="Calibri" pitchFamily="34" charset="0"/>
                 <a:ea typeface="Calibri" pitchFamily="34" charset="-122"/>
                 <a:cs typeface="Calibri" pitchFamily="34" charset="-120"/>
-                <a:hlinkClick r:id="rId9" invalidUrl="" action="" tgtFrame="" tooltip="https://www.harvardmagazine.com/2000/01/code-is-law-html" history="1" highlightClick="0" endSnd="0">
+                <a:hlinkClick r:id="rId9" invalidUrl="" action="" tgtFrame="" tooltip="https://clp.law.harvard.edu/knowledge-hub/magazine/issues/adding-value-in-the-age-of-ai/how-lawyers-can-add-value-in-the-age-of-ai/" history="1" highlightClick="0" endSnd="0">
                   <a:extLst>
                     <a:ext uri="{A12FA001-AC4F-418D-AE19-62706E023703}">
                       <ahyp:hlinkClr xmlns:ahyp="http://schemas.microsoft.com/office/drawing/2018/hyperlinkcolor" val="tx"/>
@@ -19721,7 +19811,7 @@
                   </a:extLst>
                 </a:hlinkClick>
               </a:rPr>
-              <a:t>Lessig, Code Is Law: On Liberty in Cyberspace (Harvard Magazine, 2000)</a:t>
+              <a:t>DeStefano, How Lawyers Can Add Value in the Age of AI (The Practice, 2026)</a:t>
             </a:r>
             <a:endParaRPr lang="en-US" sz="1050" dirty="0"/>
           </a:p>
@@ -19746,7 +19836,7 @@
                 <a:latin typeface="Calibri" pitchFamily="34" charset="0"/>
                 <a:ea typeface="Calibri" pitchFamily="34" charset="-122"/>
                 <a:cs typeface="Calibri" pitchFamily="34" charset="-120"/>
-                <a:hlinkClick r:id="rId10" invalidUrl="" action="" tgtFrame="" tooltip="https://dash.harvard.edu/handle/1/34390353" history="1" highlightClick="0" endSnd="0">
+                <a:hlinkClick r:id="rId10" invalidUrl="" action="" tgtFrame="" tooltip="https://www.youtube.com/watch?v=2TEVQqAZpkg" history="1" highlightClick="0" endSnd="0">
                   <a:extLst>
                     <a:ext uri="{A12FA001-AC4F-418D-AE19-62706E023703}">
                       <ahyp:hlinkClr xmlns:ahyp="http://schemas.microsoft.com/office/drawing/2018/hyperlinkcolor" val="tx"/>
@@ -19754,7 +19844,7 @@
                   </a:extLst>
                 </a:hlinkClick>
               </a:rPr>
-              <a:t>Gasser y Almeida, A Layered Model for AI Governance (2017)</a:t>
+              <a:t>Petrie-Flom Center 2026 Annual Conference, Panel 4: New Technology, New Challenges (video, 2026)</a:t>
             </a:r>
             <a:endParaRPr lang="en-US" sz="1050" dirty="0"/>
           </a:p>
@@ -19779,7 +19869,7 @@
                 <a:latin typeface="Calibri" pitchFamily="34" charset="0"/>
                 <a:ea typeface="Calibri" pitchFamily="34" charset="-122"/>
                 <a:cs typeface="Calibri" pitchFamily="34" charset="-120"/>
-                <a:hlinkClick r:id="rId11" invalidUrl="" action="" tgtFrame="" tooltip="https://jolt.law.harvard.edu/digest/a-primer-on-using-artificial-intelligence-in-the-legal-profession" history="1" highlightClick="0" endSnd="0">
+                <a:hlinkClick r:id="rId11" invalidUrl="" action="" tgtFrame="" tooltip="https://www.youtube.com/playlist?list=PL68azUN8PTNg25bFCYPRWnNjILYoOrbtg" history="1" highlightClick="0" endSnd="0">
                   <a:extLst>
                     <a:ext uri="{A12FA001-AC4F-418D-AE19-62706E023703}">
                       <ahyp:hlinkClr xmlns:ahyp="http://schemas.microsoft.com/office/drawing/2018/hyperlinkcolor" val="tx"/>
@@ -19787,7 +19877,7 @@
                   </a:extLst>
                 </a:hlinkClick>
               </a:rPr>
-              <a:t>JOLT Digest, A Primer on Using AI in the Legal Profession (2018)</a:t>
+              <a:t>Berkman Klein, AI Governance Speaker Series (Spring 2026)</a:t>
             </a:r>
             <a:endParaRPr lang="en-US" sz="1050" dirty="0"/>
           </a:p>
@@ -19812,7 +19902,7 @@
                 <a:latin typeface="Calibri" pitchFamily="34" charset="0"/>
                 <a:ea typeface="Calibri" pitchFamily="34" charset="-122"/>
                 <a:cs typeface="Calibri" pitchFamily="34" charset="-120"/>
-                <a:hlinkClick r:id="rId12" invalidUrl="" action="" tgtFrame="" tooltip="https://www.edx.org/learn/computer-science/harvard-university-cs50-s-computer-science-for-lawyers" history="1" highlightClick="0" endSnd="0">
+                <a:hlinkClick r:id="rId12" invalidUrl="" action="" tgtFrame="" tooltip="https://www.youtube.com/watch?v=MvBdRF3zw5k" history="1" highlightClick="0" endSnd="0">
                   <a:extLst>
                     <a:ext uri="{A12FA001-AC4F-418D-AE19-62706E023703}">
                       <ahyp:hlinkClr xmlns:ahyp="http://schemas.microsoft.com/office/drawing/2018/hyperlinkcolor" val="tx"/>
@@ -19820,7 +19910,7 @@
                   </a:extLst>
                 </a:hlinkClick>
               </a:rPr>
-              <a:t>CS50's Computer Science for Lawyers (HarvardX / edX)</a:t>
+              <a:t>Sunstein, Imperfect Oracle: What AI Can and Cannot Do (HLS Library Book Talk, 2025)</a:t>
             </a:r>
             <a:endParaRPr lang="en-US" sz="1050" dirty="0"/>
           </a:p>
@@ -19845,7 +19935,7 @@
                 <a:latin typeface="Calibri" pitchFamily="34" charset="0"/>
                 <a:ea typeface="Calibri" pitchFamily="34" charset="-122"/>
                 <a:cs typeface="Calibri" pitchFamily="34" charset="-120"/>
-                <a:hlinkClick r:id="rId13" invalidUrl="" action="" tgtFrame="" tooltip="https://cyber.harvard.edu/publication/2020/principled-ai" history="1" highlightClick="0" endSnd="0">
+                <a:hlinkClick r:id="rId13" invalidUrl="" action="" tgtFrame="" tooltip="https://harvardlawreview.org/print/vol-138/developments-in-the-law-artificial-intelligence/" history="1" highlightClick="0" endSnd="0">
                   <a:extLst>
                     <a:ext uri="{A12FA001-AC4F-418D-AE19-62706E023703}">
                       <ahyp:hlinkClr xmlns:ahyp="http://schemas.microsoft.com/office/drawing/2018/hyperlinkcolor" val="tx"/>
@@ -19853,7 +19943,7 @@
                   </a:extLst>
                 </a:hlinkClick>
               </a:rPr>
-              <a:t>Fjeld et al., Principled Artificial Intelligence (Berkman Klein, 2020)</a:t>
+              <a:t>Harvard Law Review, Developments in the Law — Artificial Intelligence (2025)</a:t>
             </a:r>
             <a:endParaRPr lang="en-US" sz="1050" dirty="0"/>
           </a:p>
@@ -19878,7 +19968,7 @@
                 <a:latin typeface="Calibri" pitchFamily="34" charset="0"/>
                 <a:ea typeface="Calibri" pitchFamily="34" charset="-122"/>
                 <a:cs typeface="Calibri" pitchFamily="34" charset="-120"/>
-                <a:hlinkClick r:id="rId14" invalidUrl="" action="" tgtFrame="" tooltip="https://casestudies.law.harvard.edu/cloud-act-enforcement/" history="1" highlightClick="0" endSnd="0">
+                <a:hlinkClick r:id="rId14" invalidUrl="" action="" tgtFrame="" tooltip="https://papers.ssrn.com/sol3/papers.cfm?abstract_id=5162465" history="1" highlightClick="0" endSnd="0">
                   <a:extLst>
                     <a:ext uri="{A12FA001-AC4F-418D-AE19-62706E023703}">
                       <ahyp:hlinkClr xmlns:ahyp="http://schemas.microsoft.com/office/drawing/2018/hyperlinkcolor" val="tx"/>
@@ -19886,7 +19976,7 @@
                   </a:extLst>
                 </a:hlinkClick>
               </a:rPr>
-              <a:t>CLOUD Act Enforcement (Harvard Law School Case Studies)</a:t>
+              <a:t>Bar-Gill y Sunstein, Algorithmic Harm: Protecting People in the Age of AI (2025)</a:t>
             </a:r>
             <a:endParaRPr lang="en-US" sz="1050" dirty="0"/>
           </a:p>
@@ -19911,7 +20001,7 @@
                 <a:latin typeface="Calibri" pitchFamily="34" charset="0"/>
                 <a:ea typeface="Calibri" pitchFamily="34" charset="-122"/>
                 <a:cs typeface="Calibri" pitchFamily="34" charset="-120"/>
-                <a:hlinkClick r:id="rId15" invalidUrl="" action="" tgtFrame="" tooltip="https://cyber.harvard.edu/publication/2020/modulate-case-study" history="1" highlightClick="0" endSnd="0">
+                <a:hlinkClick r:id="rId15" invalidUrl="" action="" tgtFrame="" tooltip="https://cyber.harvard.edu/publication/2020/principled-ai" history="1" highlightClick="0" endSnd="0">
                   <a:extLst>
                     <a:ext uri="{A12FA001-AC4F-418D-AE19-62706E023703}">
                       <ahyp:hlinkClr xmlns:ahyp="http://schemas.microsoft.com/office/drawing/2018/hyperlinkcolor" val="tx"/>
@@ -19919,7 +20009,7 @@
                   </a:extLst>
                 </a:hlinkClick>
               </a:rPr>
-              <a:t>Skin in the Game: Modulate AI (caso de estudio, Berkman Klein, 2020)</a:t>
+              <a:t>Fjeld et al., Principled Artificial Intelligence (Berkman Klein, 2020; marco de los ocho principios)</a:t>
             </a:r>
             <a:endParaRPr lang="en-US" sz="1050" dirty="0"/>
           </a:p>
@@ -19944,7 +20034,7 @@
                 <a:latin typeface="Calibri" pitchFamily="34" charset="0"/>
                 <a:ea typeface="Calibri" pitchFamily="34" charset="-122"/>
                 <a:cs typeface="Calibri" pitchFamily="34" charset="-120"/>
-                <a:hlinkClick r:id="rId16" invalidUrl="" action="" tgtFrame="" tooltip="https://cyber.harvard.edu/story/2019-07/intellectual-debt-great-power-comes-great-ignorance" history="1" highlightClick="0" endSnd="0">
+                <a:hlinkClick r:id="rId16" invalidUrl="" action="" tgtFrame="" tooltip="https://casestudies.law.harvard.edu/cloud-act-enforcement/" history="1" highlightClick="0" endSnd="0">
                   <a:extLst>
                     <a:ext uri="{A12FA001-AC4F-418D-AE19-62706E023703}">
                       <ahyp:hlinkClr xmlns:ahyp="http://schemas.microsoft.com/office/drawing/2018/hyperlinkcolor" val="tx"/>
@@ -19952,7 +20042,7 @@
                   </a:extLst>
                 </a:hlinkClick>
               </a:rPr>
-              <a:t>Zittrain, Intellectual Debt (Berkman Klein, 2019)</a:t>
+              <a:t>CLOUD Act Enforcement (HLS Case Studies); Skin in the Game: Modulate AI (caso, 2020)</a:t>
             </a:r>
             <a:endParaRPr lang="en-US" sz="1050" dirty="0"/>
           </a:p>
@@ -20038,7 +20128,7 @@
                 <a:latin typeface="Calibri" pitchFamily="34" charset="0"/>
                 <a:ea typeface="Calibri" pitchFamily="34" charset="-122"/>
                 <a:cs typeface="Calibri" pitchFamily="34" charset="-120"/>
-                <a:hlinkClick r:id="rId17" invalidUrl="" action="" tgtFrame="" tooltip="https://habeasdatacolombia.uniandes.edu.co/?p=2817" history="1" highlightClick="0" endSnd="0">
+                <a:hlinkClick r:id="rId17" invalidUrl="" action="" tgtFrame="" tooltip="https://www.youtube.com/watch?v=IvcNLzlJUHA" history="1" highlightClick="0" endSnd="0">
                   <a:extLst>
                     <a:ext uri="{A12FA001-AC4F-418D-AE19-62706E023703}">
                       <ahyp:hlinkClr xmlns:ahyp="http://schemas.microsoft.com/office/drawing/2018/hyperlinkcolor" val="tx"/>
@@ -20046,7 +20136,7 @@
                   </a:extLst>
                 </a:hlinkClick>
               </a:rPr>
-              <a:t>Remolina y Álvarez, Guía GECTI de responsabilidad demostrada (2018)</a:t>
+              <a:t>Desafíos del derecho en la era de la Inteligencia Artificial (Facultad de Derecho, video, febrero de 2026)</a:t>
             </a:r>
             <a:endParaRPr lang="en-US" sz="1050" dirty="0"/>
           </a:p>
@@ -20071,7 +20161,7 @@
                 <a:latin typeface="Calibri" pitchFamily="34" charset="0"/>
                 <a:ea typeface="Calibri" pitchFamily="34" charset="-122"/>
                 <a:cs typeface="Calibri" pitchFamily="34" charset="-120"/>
-                <a:hlinkClick r:id="rId18" invalidUrl="" action="" tgtFrame="" tooltip="https://derecho.uniandes.edu.co/afecta-la-inteligencia-artificial-las-decisiones-que-se-toman-sobre-las-personas/" history="1" highlightClick="0" endSnd="0">
+                <a:hlinkClick r:id="rId18" invalidUrl="" action="" tgtFrame="" tooltip="https://www.youtube.com/watch?v=veu2Gt1BqeE" history="1" highlightClick="0" endSnd="0">
                   <a:extLst>
                     <a:ext uri="{A12FA001-AC4F-418D-AE19-62706E023703}">
                       <ahyp:hlinkClr xmlns:ahyp="http://schemas.microsoft.com/office/drawing/2018/hyperlinkcolor" val="tx"/>
@@ -20079,7 +20169,7 @@
                   </a:extLst>
                 </a:hlinkClick>
               </a:rPr>
-              <a:t>¿Afecta la inteligencia artificial las decisiones que se toman sobre las personas?</a:t>
+              <a:t>Retos de la IA en la protección de los derechos humanos (Facultad de Derecho, video, mayo de 2025)</a:t>
             </a:r>
             <a:endParaRPr lang="en-US" sz="1050" dirty="0"/>
           </a:p>
@@ -20104,7 +20194,7 @@
                 <a:latin typeface="Calibri" pitchFamily="34" charset="0"/>
                 <a:ea typeface="Calibri" pitchFamily="34" charset="-122"/>
                 <a:cs typeface="Calibri" pitchFamily="34" charset="-120"/>
-                <a:hlinkClick r:id="rId19" invalidUrl="" action="" tgtFrame="" tooltip="https://ediciones.uniandes.edu.co/library/publication/derecho-de-las-tecnologias-y-las-tecnologias-para-el-derecho" history="1" highlightClick="0" endSnd="0">
+                <a:hlinkClick r:id="rId19" invalidUrl="" action="" tgtFrame="" tooltip="https://gobierno.uniandes.edu.co/la-universidad-de-los-andes-y-la-unesco-lanzan-la-version-en-espanol-de-las-directrices-para-el-uso-de-inteligencia-artificial-en-cortes-y-tribunales/" history="1" highlightClick="0" endSnd="0">
                   <a:extLst>
                     <a:ext uri="{A12FA001-AC4F-418D-AE19-62706E023703}">
                       <ahyp:hlinkClr xmlns:ahyp="http://schemas.microsoft.com/office/drawing/2018/hyperlinkcolor" val="tx"/>
@@ -20112,7 +20202,7 @@
                   </a:extLst>
                 </a:hlinkClick>
               </a:rPr>
-              <a:t>Flórez Rojas (ed.), Derecho de las tecnologías y las tecnologías para el derecho (2022)</a:t>
+              <a:t>Directrices UNESCO para el uso de IA en cortes y tribunales, versión en español (Escuela de Gobierno, 2025)</a:t>
             </a:r>
             <a:endParaRPr lang="en-US" sz="1050" dirty="0"/>
           </a:p>
@@ -20137,7 +20227,7 @@
                 <a:latin typeface="Calibri" pitchFamily="34" charset="0"/>
                 <a:ea typeface="Calibri" pitchFamily="34" charset="-122"/>
                 <a:cs typeface="Calibri" pitchFamily="34" charset="-120"/>
-                <a:hlinkClick r:id="rId20" invalidUrl="" action="" tgtFrame="" tooltip="https://derecho.uniandes.edu.co/es/toolkit-etico-legal-de-inteligencia-artificial" history="1" highlightClick="0" endSnd="0">
+                <a:hlinkClick r:id="rId20" invalidUrl="" action="" tgtFrame="" tooltip="https://algoritmos.uniandes.edu.co/xxv-jornadas-gecti-derecho-tecnologia-y-sociedad-digital/" history="1" highlightClick="0" endSnd="0">
                   <a:extLst>
                     <a:ext uri="{A12FA001-AC4F-418D-AE19-62706E023703}">
                       <ahyp:hlinkClr xmlns:ahyp="http://schemas.microsoft.com/office/drawing/2018/hyperlinkcolor" val="tx"/>
@@ -20145,7 +20235,7 @@
                   </a:extLst>
                 </a:hlinkClick>
               </a:rPr>
-              <a:t>Toolkit ético legal de inteligencia artificial (Facultad de Derecho y GECTI)</a:t>
+              <a:t>XXV Jornadas GECTI: Derecho, Tecnología y Sociedad Digital (mayo de 2026)</a:t>
             </a:r>
             <a:endParaRPr lang="en-US" sz="1050" dirty="0"/>
           </a:p>
@@ -20170,7 +20260,7 @@
                 <a:latin typeface="Calibri" pitchFamily="34" charset="0"/>
                 <a:ea typeface="Calibri" pitchFamily="34" charset="-122"/>
                 <a:cs typeface="Calibri" pitchFamily="34" charset="-120"/>
-                <a:hlinkClick r:id="rId21" invalidUrl="" action="" tgtFrame="" tooltip="https://habeasdatacolombia.uniandes.edu.co/jurisprudencia/" history="1" highlightClick="0" endSnd="0">
+                <a:hlinkClick r:id="rId21" invalidUrl="" action="" tgtFrame="" tooltip="https://derecho.uniandes.edu.co/es/toolkit-etico-legal-de-inteligencia-artificial" history="1" highlightClick="0" endSnd="0">
                   <a:extLst>
                     <a:ext uri="{A12FA001-AC4F-418D-AE19-62706E023703}">
                       <ahyp:hlinkClr xmlns:ahyp="http://schemas.microsoft.com/office/drawing/2018/hyperlinkcolor" val="tx"/>
@@ -20178,7 +20268,7 @@
                   </a:extLst>
                 </a:hlinkClick>
               </a:rPr>
-              <a:t>Observatorio Ciro Angarita Barón: jurisprudencia de habeas data</a:t>
+              <a:t>Toolkit ético legal de inteligencia artificial (Facultad de Derecho y GECTI)</a:t>
             </a:r>
             <a:endParaRPr lang="en-US" sz="1050" dirty="0"/>
           </a:p>
@@ -20203,7 +20293,7 @@
                 <a:latin typeface="Calibri" pitchFamily="34" charset="0"/>
                 <a:ea typeface="Calibri" pitchFamily="34" charset="-122"/>
                 <a:cs typeface="Calibri" pitchFamily="34" charset="-120"/>
-                <a:hlinkClick r:id="rId22" invalidUrl="" action="" tgtFrame="" tooltip="https://gecti.uniandes.edu.co/publicaciones/" history="1" highlightClick="0" endSnd="0">
+                <a:hlinkClick r:id="rId22" invalidUrl="" action="" tgtFrame="" tooltip="https://derecho.uniandes.edu.co/afecta-la-inteligencia-artificial-las-decisiones-que-se-toman-sobre-las-personas/" history="1" highlightClick="0" endSnd="0">
                   <a:extLst>
                     <a:ext uri="{A12FA001-AC4F-418D-AE19-62706E023703}">
                       <ahyp:hlinkClr xmlns:ahyp="http://schemas.microsoft.com/office/drawing/2018/hyperlinkcolor" val="tx"/>
@@ -20211,7 +20301,7 @@
                   </a:extLst>
                 </a:hlinkClick>
               </a:rPr>
-              <a:t>GECTI: publicaciones y eventos</a:t>
+              <a:t>¿Afecta la inteligencia artificial las decisiones que se toman sobre las personas? (Facultad de Derecho)</a:t>
             </a:r>
             <a:endParaRPr lang="en-US" sz="1050" dirty="0"/>
           </a:p>
@@ -20236,7 +20326,7 @@
                 <a:latin typeface="Calibri" pitchFamily="34" charset="0"/>
                 <a:ea typeface="Calibri" pitchFamily="34" charset="-122"/>
                 <a:cs typeface="Calibri" pitchFamily="34" charset="-120"/>
-                <a:hlinkClick r:id="rId23" invalidUrl="" action="" tgtFrame="" tooltip="https://www.youtube.com/@facultaddederechouniversid8608/streams" history="1" highlightClick="0" endSnd="0">
+                <a:hlinkClick r:id="rId23" invalidUrl="" action="" tgtFrame="" tooltip="https://habeasdatacolombia.uniandes.edu.co/?p=2817" history="1" highlightClick="0" endSnd="0">
                   <a:extLst>
                     <a:ext uri="{A12FA001-AC4F-418D-AE19-62706E023703}">
                       <ahyp:hlinkClr xmlns:ahyp="http://schemas.microsoft.com/office/drawing/2018/hyperlinkcolor" val="tx"/>
@@ -20244,7 +20334,40 @@
                   </a:extLst>
                 </a:hlinkClick>
               </a:rPr>
-              <a:t>Canal de YouTube de la Facultad de Derecho (conferencias sobre IA, 2024-2026)</a:t>
+              <a:t>Guía GECTI de responsabilidad demostrada en transferencias internacionales (2018; herramienta)</a:t>
+            </a:r>
+            <a:endParaRPr lang="en-US" sz="1050" dirty="0"/>
+          </a:p>
+          <a:p>
+            <a:pPr marL="342900" indent="-342900">
+              <a:spcAft>
+                <a:spcPts val="500"/>
+              </a:spcAft>
+              <a:buSzPct val="100000"/>
+              <a:buChar char="•"/>
+            </a:pPr>
+            <a:r>
+              <a:rPr lang="en-US" sz="1050" u="sng" dirty="0">
+                <a:solidFill>
+                  <a:srgbClr val="4A5568"/>
+                </a:solidFill>
+                <a:uFill>
+                  <a:solidFill>
+                    <a:srgbClr val="B0BAC6"/>
+                  </a:solidFill>
+                </a:uFill>
+                <a:latin typeface="Calibri" pitchFamily="34" charset="0"/>
+                <a:ea typeface="Calibri" pitchFamily="34" charset="-122"/>
+                <a:cs typeface="Calibri" pitchFamily="34" charset="-120"/>
+                <a:hlinkClick r:id="rId24" invalidUrl="" action="" tgtFrame="" tooltip="https://derecho.uniandes.edu.co/evento/uniandes-legal-fest-2026/" history="1" highlightClick="0" endSnd="0">
+                  <a:extLst>
+                    <a:ext uri="{A12FA001-AC4F-418D-AE19-62706E023703}">
+                      <ahyp:hlinkClr xmlns:ahyp="http://schemas.microsoft.com/office/drawing/2018/hyperlinkcolor" val="tx"/>
+                    </a:ext>
+                  </a:extLst>
+                </a:hlinkClick>
+              </a:rPr>
+              <a:t>Uniandes Legal Fest 2026 (Facultad de Derecho)</a:t>
             </a:r>
             <a:endParaRPr lang="en-US" sz="1050" dirty="0"/>
           </a:p>
@@ -20283,7 +20406,7 @@
                 <a:ea typeface="Calibri" pitchFamily="34" charset="-122"/>
                 <a:cs typeface="Calibri" pitchFamily="34" charset="-120"/>
               </a:rPr>
-              <a:t>Cada título es un enlace. Catálogo completo (155 fuentes con URL y estado de verificación): FUENTES.md / FUENTES.docx en la carpeta de la conferencia.</a:t>
+              <a:t>Cada título es un enlace. Videos en sala: solo 2025-2026. Catálogo completo con URL, año y estado de verificación: FUENTES.md / FUENTES.docx en la carpeta de la conferencia.</a:t>
             </a:r>
             <a:endParaRPr lang="en-US" sz="1000" dirty="0"/>
           </a:p>
@@ -20512,8 +20635,8 @@
         </p:nvSpPr>
         <p:spPr>
           <a:xfrm>
-            <a:off x="548640" y="1371600"/>
-            <a:ext cx="5669280" cy="365760"/>
+            <a:off x="548640" y="1325880"/>
+            <a:ext cx="5669280" cy="457200"/>
           </a:xfrm>
           <a:prstGeom prst="rect">
             <a:avLst/>
@@ -20529,7 +20652,7 @@
               <a:buNone/>
             </a:pPr>
             <a:r>
-              <a:rPr lang="en-US" sz="1500" b="1" dirty="0">
+              <a:rPr lang="en-US" sz="1400" b="1" dirty="0">
                 <a:solidFill>
                   <a:srgbClr val="0F7C90"/>
                 </a:solidFill>
@@ -20537,9 +20660,9 @@
                 <a:ea typeface="Calibri" pitchFamily="34" charset="-122"/>
                 <a:cs typeface="Calibri" pitchFamily="34" charset="-120"/>
               </a:rPr>
-              <a:t>Lawrence Lessig · «Code Is Law» (Harvard Magazine, 2000)</a:t>
-            </a:r>
-            <a:endParaRPr lang="en-US" sz="1500" dirty="0"/>
+              <a:t>Marco clásico · Lessig, «Code Is Law» (Harvard Magazine, 2000)</a:t>
+            </a:r>
+            <a:endParaRPr lang="en-US" sz="1400" dirty="0"/>
           </a:p>
         </p:txBody>
       </p:sp>
@@ -20551,7 +20674,7 @@
         </p:nvSpPr>
         <p:spPr>
           <a:xfrm>
-            <a:off x="548640" y="1737360"/>
+            <a:off x="548640" y="1783080"/>
             <a:ext cx="5669280" cy="548640"/>
           </a:xfrm>
           <a:prstGeom prst="rect">
@@ -21049,8 +21172,8 @@
         </p:nvSpPr>
         <p:spPr>
           <a:xfrm>
-            <a:off x="6675120" y="1371600"/>
-            <a:ext cx="5029200" cy="548640"/>
+            <a:off x="6675120" y="1325880"/>
+            <a:ext cx="5029200" cy="640080"/>
           </a:xfrm>
           <a:prstGeom prst="rect">
             <a:avLst/>
@@ -21066,7 +21189,7 @@
               <a:buNone/>
             </a:pPr>
             <a:r>
-              <a:rPr lang="en-US" sz="1500" b="1" dirty="0">
+              <a:rPr lang="en-US" sz="1400" b="1" dirty="0">
                 <a:solidFill>
                   <a:srgbClr val="0F7C90"/>
                 </a:solidFill>
@@ -21074,9 +21197,9 @@
                 <a:ea typeface="Calibri" pitchFamily="34" charset="-122"/>
                 <a:cs typeface="Calibri" pitchFamily="34" charset="-120"/>
               </a:rPr>
-              <a:t>Urs Gasser y Virgílio Almeida · «A Layered Model for AI Governance» (Harvard, 2017)</a:t>
-            </a:r>
-            <a:endParaRPr lang="en-US" sz="1500" dirty="0"/>
+              <a:t>Marco clásico · Gasser y Almeida, «A Layered Model for AI Governance» (Harvard, 2017)</a:t>
+            </a:r>
+            <a:endParaRPr lang="en-US" sz="1400" dirty="0"/>
           </a:p>
         </p:txBody>
       </p:sp>
@@ -24165,7 +24288,7 @@
                           <a:ea typeface="Calibri" pitchFamily="34" charset="-122"/>
                           <a:cs typeface="Calibri" pitchFamily="34" charset="-120"/>
                         </a:rPr>
-                        <a:t>Video 1 · La IA en el trabajo del abogado (Harvard)</a:t>
+                        <a:t>Video 1 · Desafíos del derecho en la era de la IA (Uniandes, 2026)</a:t>
                       </a:r>
                       <a:endParaRPr lang="en-US" sz="1150" dirty="0">
                         <a:latin typeface="Calibri" charset="0"/>
@@ -24987,7 +25110,7 @@
                           <a:ea typeface="Calibri" pitchFamily="34" charset="-122"/>
                           <a:cs typeface="Calibri" pitchFamily="34" charset="-120"/>
                         </a:rPr>
-                        <a:t>Video 2 · Del contrato electrónico al smart contract (Externado)</a:t>
+                        <a:t>Video 2 · Fraude cibernético por canales móviles y prueba electrónica (Externado, 2025)</a:t>
                       </a:r>
                       <a:endParaRPr lang="en-US" sz="1150" dirty="0">
                         <a:latin typeface="Calibri" charset="0"/>
@@ -26083,7 +26206,7 @@
                           <a:ea typeface="Calibri" pitchFamily="34" charset="-122"/>
                           <a:cs typeface="Calibri" pitchFamily="34" charset="-120"/>
                         </a:rPr>
-                        <a:t>Video 3 · Datos personales en la nube y en sistemas de IA (Uniandes)</a:t>
+                        <a:t>Video 3 · Biometría y sistemas de IA: caso Mercado Libre con la SIC (Externado, 2025)</a:t>
                       </a:r>
                       <a:endParaRPr lang="en-US" sz="1150" dirty="0">
                         <a:latin typeface="Calibri" charset="0"/>
@@ -26631,7 +26754,7 @@
                           <a:ea typeface="Calibri" pitchFamily="34" charset="-122"/>
                           <a:cs typeface="Calibri" pitchFamily="34" charset="-120"/>
                         </a:rPr>
-                        <a:t>Video 4 · Apertura y supervisión de la IA (Harvard)</a:t>
+                        <a:t>Video 4 · Algoritmos que deciden sobre personas (Harvard, 2026)</a:t>
                       </a:r>
                       <a:endParaRPr lang="en-US" sz="1150" dirty="0">
                         <a:latin typeface="Calibri" charset="0"/>
@@ -27428,7 +27551,7 @@
               <a:buNone/>
             </a:pPr>
             <a:r>
-              <a:rPr lang="en-US" sz="2800" b="1" dirty="0">
+              <a:rPr lang="en-US" sz="2400" b="1" dirty="0">
                 <a:solidFill>
                   <a:srgbClr val="1B2A41"/>
                 </a:solidFill>
@@ -27436,9 +27559,9 @@
                 <a:ea typeface="Cambria" pitchFamily="34" charset="-122"/>
                 <a:cs typeface="Cambria" pitchFamily="34" charset="-120"/>
               </a:rPr>
-              <a:t>Videos de la sesión: enlaces directos</a:t>
-            </a:r>
-            <a:endParaRPr lang="en-US" sz="2800" dirty="0"/>
+              <a:t>Videos de la sesión (2025-2026): enlaces directos</a:t>
+            </a:r>
+            <a:endParaRPr lang="en-US" sz="2400" dirty="0"/>
           </a:p>
         </p:txBody>
       </p:sp>
@@ -27671,7 +27794,7 @@
                 <a:ea typeface="Calibri" pitchFamily="34" charset="-122"/>
                 <a:cs typeface="Calibri" pitchFamily="34" charset="-120"/>
               </a:rPr>
-              <a:t>Understanding Impacts of AI on the Legal Profession</a:t>
+              <a:t>Desafíos del derecho en la era de la Inteligencia Artificial</a:t>
             </a:r>
             <a:endParaRPr lang="en-US" sz="1300" dirty="0"/>
           </a:p>
@@ -27710,7 +27833,7 @@
                 <a:ea typeface="Calibri" pitchFamily="34" charset="-122"/>
                 <a:cs typeface="Calibri" pitchFamily="34" charset="-120"/>
               </a:rPr>
-              <a:t>CS50's Computer Science for Lawyers · Harvard · 8-14 min · fragmento de 4-5 min</a:t>
+              <a:t>Facultad de Derecho · Universidad de los Andes · 6 de febrero de 2026 · 8-14 min · fragmento de 4-5 min</a:t>
             </a:r>
             <a:endParaRPr lang="en-US" sz="1050" dirty="0"/>
           </a:p>
@@ -27780,7 +27903,7 @@
                 <a:latin typeface="Calibri" pitchFamily="34" charset="0"/>
                 <a:ea typeface="Calibri" pitchFamily="34" charset="-122"/>
                 <a:cs typeface="Calibri" pitchFamily="34" charset="-120"/>
-                <a:hlinkClick r:id="rId1" invalidUrl="" action="" tgtFrame="" tooltip="https://www.youtube.com/watch?v=Y8UHDl2IJOM" history="1" highlightClick="0" endSnd="0">
+                <a:hlinkClick r:id="rId1" invalidUrl="" action="" tgtFrame="" tooltip="https://www.youtube.com/watch?v=IvcNLzlJUHA" history="1" highlightClick="0" endSnd="0">
                   <a:extLst>
                     <a:ext uri="{A12FA001-AC4F-418D-AE19-62706E023703}">
                       <ahyp:hlinkClr xmlns:ahyp="http://schemas.microsoft.com/office/drawing/2018/hyperlinkcolor" val="tx"/>
@@ -27831,7 +27954,7 @@
                 <a:latin typeface="Calibri" pitchFamily="34" charset="0"/>
                 <a:ea typeface="Calibri" pitchFamily="34" charset="-122"/>
                 <a:cs typeface="Calibri" pitchFamily="34" charset="-120"/>
-                <a:hlinkClick r:id="rId2" invalidUrl="" action="" tgtFrame="" tooltip="https://www.youtube.com/watch?v=Y8UHDl2IJOM" history="1" highlightClick="0" endSnd="0">
+                <a:hlinkClick r:id="rId2" invalidUrl="" action="" tgtFrame="" tooltip="https://www.youtube.com/watch?v=IvcNLzlJUHA" history="1" highlightClick="0" endSnd="0">
                   <a:extLst>
                     <a:ext uri="{A12FA001-AC4F-418D-AE19-62706E023703}">
                       <ahyp:hlinkClr xmlns:ahyp="http://schemas.microsoft.com/office/drawing/2018/hyperlinkcolor" val="tx"/>
@@ -27839,7 +27962,7 @@
                   </a:extLst>
                 </a:hlinkClick>
               </a:rPr>
-              <a:t>https://www.youtube.com/watch?v=Y8UHDl2IJOM</a:t>
+              <a:t>https://www.youtube.com/watch?v=IvcNLzlJUHA</a:t>
             </a:r>
             <a:endParaRPr lang="en-US" sz="950" dirty="0"/>
           </a:p>
@@ -27969,7 +28092,7 @@
                 <a:ea typeface="Calibri" pitchFamily="34" charset="-122"/>
                 <a:cs typeface="Calibri" pitchFamily="34" charset="-120"/>
               </a:rPr>
-              <a:t>Del contrato electrónico a los smart contracts: perspectivas y prospectiva</a:t>
+              <a:t>Webinar: medidas para mitigar el fraude cibernético por medio de servicios móviles</a:t>
             </a:r>
             <a:endParaRPr lang="en-US" sz="1300" dirty="0"/>
           </a:p>
@@ -28008,7 +28131,7 @@
                 <a:ea typeface="Calibri" pitchFamily="34" charset="-122"/>
                 <a:cs typeface="Calibri" pitchFamily="34" charset="-120"/>
               </a:rPr>
-              <a:t>Daniel Peña Valenzuela · Universidad Externado de Colombia (2018) · 35-41 min · fragmento de 6 min</a:t>
+              <a:t>Dpto. de Derecho, Comunicaciones y Tecnologías de la Información · Externado · 23 de julio de 2025 · 35-41 min · fragmento de 6 min</a:t>
             </a:r>
             <a:endParaRPr lang="en-US" sz="1050" dirty="0"/>
           </a:p>
@@ -28078,7 +28201,7 @@
                 <a:latin typeface="Calibri" pitchFamily="34" charset="0"/>
                 <a:ea typeface="Calibri" pitchFamily="34" charset="-122"/>
                 <a:cs typeface="Calibri" pitchFamily="34" charset="-120"/>
-                <a:hlinkClick r:id="rId3" invalidUrl="" action="" tgtFrame="" tooltip="https://www.youtube.com/watch?v=-ihaM9HKMvg" history="1" highlightClick="0" endSnd="0">
+                <a:hlinkClick r:id="rId3" invalidUrl="" action="" tgtFrame="" tooltip="https://www.uexternado.edu.co/derecho/departamento-derecho-las-telecomunicaciones-2/seminarios-web-2025/" history="1" highlightClick="0" endSnd="0">
                   <a:extLst>
                     <a:ext uri="{A12FA001-AC4F-418D-AE19-62706E023703}">
                       <ahyp:hlinkClr xmlns:ahyp="http://schemas.microsoft.com/office/drawing/2018/hyperlinkcolor" val="tx"/>
@@ -28086,7 +28209,7 @@
                   </a:extLst>
                 </a:hlinkClick>
               </a:rPr>
-              <a:t>▶  Abrir el video</a:t>
+              <a:t>▶  Abrir la grabación</a:t>
             </a:r>
             <a:endParaRPr lang="en-US" sz="1300" dirty="0"/>
           </a:p>
@@ -28129,7 +28252,7 @@
                 <a:latin typeface="Calibri" pitchFamily="34" charset="0"/>
                 <a:ea typeface="Calibri" pitchFamily="34" charset="-122"/>
                 <a:cs typeface="Calibri" pitchFamily="34" charset="-120"/>
-                <a:hlinkClick r:id="rId4" invalidUrl="" action="" tgtFrame="" tooltip="https://www.youtube.com/watch?v=-ihaM9HKMvg" history="1" highlightClick="0" endSnd="0">
+                <a:hlinkClick r:id="rId4" invalidUrl="" action="" tgtFrame="" tooltip="https://www.uexternado.edu.co/derecho/departamento-derecho-las-telecomunicaciones-2/seminarios-web-2025/" history="1" highlightClick="0" endSnd="0">
                   <a:extLst>
                     <a:ext uri="{A12FA001-AC4F-418D-AE19-62706E023703}">
                       <ahyp:hlinkClr xmlns:ahyp="http://schemas.microsoft.com/office/drawing/2018/hyperlinkcolor" val="tx"/>
@@ -28137,7 +28260,7 @@
                   </a:extLst>
                 </a:hlinkClick>
               </a:rPr>
-              <a:t>https://www.youtube.com/watch?v=-ihaM9HKMvg</a:t>
+              <a:t>uexternado.edu.co › Seminarios web 2025 (grabación)</a:t>
             </a:r>
             <a:endParaRPr lang="en-US" sz="950" dirty="0"/>
           </a:p>
@@ -28267,7 +28390,7 @@
                 <a:ea typeface="Calibri" pitchFamily="34" charset="-122"/>
                 <a:cs typeface="Calibri" pitchFamily="34" charset="-120"/>
               </a:rPr>
-              <a:t>Protección de datos personales · 4 Foro Cloud Computing (1/2)</a:t>
+              <a:t>Biometría bajo la lupa: el caso Mercado Libre y las nuevas reglas de juego</a:t>
             </a:r>
             <a:endParaRPr lang="en-US" sz="1300" dirty="0"/>
           </a:p>
@@ -28306,7 +28429,7 @@
                 <a:ea typeface="Calibri" pitchFamily="34" charset="-122"/>
                 <a:cs typeface="Calibri" pitchFamily="34" charset="-120"/>
               </a:rPr>
-              <a:t>Nelson Remolina Angarita · Universidad de los Andes (GECTI) · 72-80 min · fragmento de 5 min</a:t>
+              <a:t>Con Carolina García Molina (SIC) y María del Pilar Cortés · Externado · 3 de julio de 2025 · 72-80 min · fragmento de 5 min</a:t>
             </a:r>
             <a:endParaRPr lang="en-US" sz="1050" dirty="0"/>
           </a:p>
@@ -28376,7 +28499,7 @@
                 <a:latin typeface="Calibri" pitchFamily="34" charset="0"/>
                 <a:ea typeface="Calibri" pitchFamily="34" charset="-122"/>
                 <a:cs typeface="Calibri" pitchFamily="34" charset="-120"/>
-                <a:hlinkClick r:id="rId5" invalidUrl="" action="" tgtFrame="" tooltip="https://www.youtube.com/watch?v=SSalLuF8SCw" history="1" highlightClick="0" endSnd="0">
+                <a:hlinkClick r:id="rId5" invalidUrl="" action="" tgtFrame="" tooltip="https://www.uexternado.edu.co/departamento-de-derecho-comunicaciones-y-tecnologias-de-la-informacion/biometria-bajo-la-lupa-el-caso-mercado-libre-y-las-nuevas-reglas-de-juego/" history="1" highlightClick="0" endSnd="0">
                   <a:extLst>
                     <a:ext uri="{A12FA001-AC4F-418D-AE19-62706E023703}">
                       <ahyp:hlinkClr xmlns:ahyp="http://schemas.microsoft.com/office/drawing/2018/hyperlinkcolor" val="tx"/>
@@ -28384,7 +28507,7 @@
                   </a:extLst>
                 </a:hlinkClick>
               </a:rPr>
-              <a:t>▶  Abrir el video</a:t>
+              <a:t>▶  Abrir la grabación</a:t>
             </a:r>
             <a:endParaRPr lang="en-US" sz="1300" dirty="0"/>
           </a:p>
@@ -28427,7 +28550,7 @@
                 <a:latin typeface="Calibri" pitchFamily="34" charset="0"/>
                 <a:ea typeface="Calibri" pitchFamily="34" charset="-122"/>
                 <a:cs typeface="Calibri" pitchFamily="34" charset="-120"/>
-                <a:hlinkClick r:id="rId6" invalidUrl="" action="" tgtFrame="" tooltip="https://www.youtube.com/watch?v=SSalLuF8SCw" history="1" highlightClick="0" endSnd="0">
+                <a:hlinkClick r:id="rId6" invalidUrl="" action="" tgtFrame="" tooltip="https://www.uexternado.edu.co/departamento-de-derecho-comunicaciones-y-tecnologias-de-la-informacion/biometria-bajo-la-lupa-el-caso-mercado-libre-y-las-nuevas-reglas-de-juego/" history="1" highlightClick="0" endSnd="0">
                   <a:extLst>
                     <a:ext uri="{A12FA001-AC4F-418D-AE19-62706E023703}">
                       <ahyp:hlinkClr xmlns:ahyp="http://schemas.microsoft.com/office/drawing/2018/hyperlinkcolor" val="tx"/>
@@ -28435,7 +28558,7 @@
                   </a:extLst>
                 </a:hlinkClick>
               </a:rPr>
-              <a:t>https://www.youtube.com/watch?v=SSalLuF8SCw</a:t>
+              <a:t>uexternado.edu.co › Biometría bajo la lupa (reseña y grabación)</a:t>
             </a:r>
             <a:endParaRPr lang="en-US" sz="950" dirty="0"/>
           </a:p>
@@ -28565,7 +28688,7 @@
                 <a:ea typeface="Calibri" pitchFamily="34" charset="-122"/>
                 <a:cs typeface="Calibri" pitchFamily="34" charset="-120"/>
               </a:rPr>
-              <a:t>Openness and Oversight of Artificial Intelligence</a:t>
+              <a:t>Petrie-Flom Center 2026 Annual Conference · Panel 4: New Technology, New Challenges</a:t>
             </a:r>
             <a:endParaRPr lang="en-US" sz="1300" dirty="0"/>
           </a:p>
@@ -28604,7 +28727,7 @@
                 <a:ea typeface="Calibri" pitchFamily="34" charset="-122"/>
                 <a:cs typeface="Calibri" pitchFamily="34" charset="-120"/>
               </a:rPr>
-              <a:t>Jonathan Zittrain · Harvard Law School / Berkman Klein Center (2017) · 103-106 min · clip de 3 min</a:t>
+              <a:t>Harvard Law School · 2026 · segmento «Algorithms That Choose Life: a True Lifecycle Approach for AI Governance» · 103-106 min · clip de 3 min</a:t>
             </a:r>
             <a:endParaRPr lang="en-US" sz="1050" dirty="0"/>
           </a:p>
@@ -28674,7 +28797,7 @@
                 <a:latin typeface="Calibri" pitchFamily="34" charset="0"/>
                 <a:ea typeface="Calibri" pitchFamily="34" charset="-122"/>
                 <a:cs typeface="Calibri" pitchFamily="34" charset="-120"/>
-                <a:hlinkClick r:id="rId7" invalidUrl="" action="" tgtFrame="" tooltip="https://www.youtube.com/watch?v=Jf5o1Dlv28w" history="1" highlightClick="0" endSnd="0">
+                <a:hlinkClick r:id="rId7" invalidUrl="" action="" tgtFrame="" tooltip="https://www.youtube.com/watch?v=2TEVQqAZpkg" history="1" highlightClick="0" endSnd="0">
                   <a:extLst>
                     <a:ext uri="{A12FA001-AC4F-418D-AE19-62706E023703}">
                       <ahyp:hlinkClr xmlns:ahyp="http://schemas.microsoft.com/office/drawing/2018/hyperlinkcolor" val="tx"/>
@@ -28725,7 +28848,7 @@
                 <a:latin typeface="Calibri" pitchFamily="34" charset="0"/>
                 <a:ea typeface="Calibri" pitchFamily="34" charset="-122"/>
                 <a:cs typeface="Calibri" pitchFamily="34" charset="-120"/>
-                <a:hlinkClick r:id="rId8" invalidUrl="" action="" tgtFrame="" tooltip="https://www.youtube.com/watch?v=Jf5o1Dlv28w" history="1" highlightClick="0" endSnd="0">
+                <a:hlinkClick r:id="rId8" invalidUrl="" action="" tgtFrame="" tooltip="https://www.youtube.com/watch?v=2TEVQqAZpkg" history="1" highlightClick="0" endSnd="0">
                   <a:extLst>
                     <a:ext uri="{A12FA001-AC4F-418D-AE19-62706E023703}">
                       <ahyp:hlinkClr xmlns:ahyp="http://schemas.microsoft.com/office/drawing/2018/hyperlinkcolor" val="tx"/>
@@ -28733,7 +28856,7 @@
                   </a:extLst>
                 </a:hlinkClick>
               </a:rPr>
-              <a:t>https://www.youtube.com/watch?v=Jf5o1Dlv28w</a:t>
+              <a:t>https://www.youtube.com/watch?v=2TEVQqAZpkg</a:t>
             </a:r>
             <a:endParaRPr lang="en-US" sz="950" dirty="0"/>
           </a:p>
@@ -28854,7 +28977,7 @@
                 <a:latin typeface="Calibri" pitchFamily="34" charset="0"/>
                 <a:ea typeface="Calibri" pitchFamily="34" charset="-122"/>
                 <a:cs typeface="Calibri" pitchFamily="34" charset="-120"/>
-                <a:hlinkClick r:id="rId9" invalidUrl="" action="" tgtFrame="" tooltip="https://www.youtube.com/watch?v=IvcNLzlJUHA" history="1" highlightClick="0" endSnd="0">
+                <a:hlinkClick r:id="rId9" invalidUrl="" action="" tgtFrame="" tooltip="https://www.youtube.com/watch?v=veu2Gt1BqeE" history="1" highlightClick="0" endSnd="0">
                   <a:extLst>
                     <a:ext uri="{A12FA001-AC4F-418D-AE19-62706E023703}">
                       <ahyp:hlinkClr xmlns:ahyp="http://schemas.microsoft.com/office/drawing/2018/hyperlinkcolor" val="tx"/>
@@ -28862,7 +28985,7 @@
                   </a:extLst>
                 </a:hlinkClick>
               </a:rPr>
-              <a:t>Desafíos del derecho en la era de la Inteligencia Artificial (Facultad de Derecho Uniandes, 2026)</a:t>
+              <a:t>Retos de la inteligencia artificial en la protección de los derechos humanos (Facultad de Derecho Uniandes, 12 de mayo de 2025)</a:t>
             </a:r>
             <a:endParaRPr lang="en-US" sz="950" dirty="0"/>
           </a:p>
@@ -28944,7 +29067,7 @@
                 <a:latin typeface="Calibri" pitchFamily="34" charset="0"/>
                 <a:ea typeface="Calibri" pitchFamily="34" charset="-122"/>
                 <a:cs typeface="Calibri" pitchFamily="34" charset="-120"/>
-                <a:hlinkClick r:id="rId10" invalidUrl="" action="" tgtFrame="" tooltip="https://www.youtube.com/watch?v=-lm4xlX9WcA" history="1" highlightClick="0" endSnd="0">
+                <a:hlinkClick r:id="rId10" invalidUrl="" action="" tgtFrame="" tooltip="https://www.youtube.com/watch?v=MvBdRF3zw5k" history="1" highlightClick="0" endSnd="0">
                   <a:extLst>
                     <a:ext uri="{A12FA001-AC4F-418D-AE19-62706E023703}">
                       <ahyp:hlinkClr xmlns:ahyp="http://schemas.microsoft.com/office/drawing/2018/hyperlinkcolor" val="tx"/>
@@ -28952,7 +29075,7 @@
                   </a:extLst>
                 </a:hlinkClick>
               </a:rPr>
-              <a:t>La regulación de la IA y el Estado de Derecho: retos y oportunidades (Facultad de Derecho Uniandes, 2024)</a:t>
+              <a:t>Cass Sunstein, «Imperfect Oracle: What AI Can and Cannot Do», Harvard Law School Library Book Talk (12 de noviembre de 2025)</a:t>
             </a:r>
             <a:endParaRPr lang="en-US" sz="950" dirty="0"/>
           </a:p>
@@ -28991,7 +29114,7 @@
                 <a:ea typeface="Calibri" pitchFamily="34" charset="-122"/>
                 <a:cs typeface="Calibri" pitchFamily="34" charset="-120"/>
               </a:rPr>
-              <a:t>Video 3 →</a:t>
+              <a:t>Video 2 →</a:t>
             </a:r>
             <a:endParaRPr lang="en-US" sz="950" dirty="0"/>
           </a:p>
@@ -29034,7 +29157,7 @@
                 <a:latin typeface="Calibri" pitchFamily="34" charset="0"/>
                 <a:ea typeface="Calibri" pitchFamily="34" charset="-122"/>
                 <a:cs typeface="Calibri" pitchFamily="34" charset="-120"/>
-                <a:hlinkClick r:id="rId11" invalidUrl="" action="" tgtFrame="" tooltip="https://www.uexternado.edu.co/derecho/departamento-derecho-las-telecomunicaciones-2/seminarios-web-2025/" history="1" highlightClick="0" endSnd="0">
+                <a:hlinkClick r:id="rId11" invalidUrl="" action="" tgtFrame="" tooltip="https://www.youtube.com/playlist?list=PLLdYhVJsMEXJsQw_DL_dNOejiIpp1OERr" history="1" highlightClick="0" endSnd="0">
                   <a:extLst>
                     <a:ext uri="{A12FA001-AC4F-418D-AE19-62706E023703}">
                       <ahyp:hlinkClr xmlns:ahyp="http://schemas.microsoft.com/office/drawing/2018/hyperlinkcolor" val="tx"/>
@@ -29042,7 +29165,7 @@
                   </a:extLst>
                 </a:hlinkClick>
               </a:rPr>
-              <a:t>Seminarios web 2025 del Departamento de Derecho TIC (Externado): sesión de biometría</a:t>
+              <a:t>Lista del Departamento de Derecho, Comunicaciones y Tecnologías de la Información en YouTube (Externado)</a:t>
             </a:r>
             <a:endParaRPr lang="en-US" sz="950" dirty="0"/>
           </a:p>
@@ -29124,7 +29247,7 @@
                 <a:latin typeface="Calibri" pitchFamily="34" charset="0"/>
                 <a:ea typeface="Calibri" pitchFamily="34" charset="-122"/>
                 <a:cs typeface="Calibri" pitchFamily="34" charset="-120"/>
-                <a:hlinkClick r:id="rId12" invalidUrl="" action="" tgtFrame="" tooltip="https://www.youtube.com/watch?v=IZOQWriItd8" history="1" highlightClick="0" endSnd="0">
+                <a:hlinkClick r:id="rId12" invalidUrl="" action="" tgtFrame="" tooltip="https://www.uexternado.edu.co/departamento-de-derecho-comunicaciones-y-tecnologias-de-la-informacion/seminarios-web-2026/" history="1" highlightClick="0" endSnd="0">
                   <a:extLst>
                     <a:ext uri="{A12FA001-AC4F-418D-AE19-62706E023703}">
                       <ahyp:hlinkClr xmlns:ahyp="http://schemas.microsoft.com/office/drawing/2018/hyperlinkcolor" val="tx"/>
@@ -29132,7 +29255,7 @@
                   </a:extLst>
                 </a:hlinkClick>
               </a:rPr>
-              <a:t>Cuarta sesión de la Mesa de Trabajo Multiactor sobre Regulación de IA en Colombia (Externado y Uniandes)</a:t>
+              <a:t>Seminarios web 2026 del Departamento de Derecho TIC (Externado): IA y derechos digitales</a:t>
             </a:r>
             <a:endParaRPr lang="en-US" sz="950" dirty="0"/>
           </a:p>
@@ -29171,7 +29294,7 @@
                 <a:ea typeface="Calibri" pitchFamily="34" charset="-122"/>
                 <a:cs typeface="Calibri" pitchFamily="34" charset="-120"/>
               </a:rPr>
-              <a:t>Video 4 →</a:t>
+              <a:t>Video 3 →</a:t>
             </a:r>
             <a:endParaRPr lang="en-US" sz="950" dirty="0"/>
           </a:p>
@@ -29214,7 +29337,7 @@
                 <a:latin typeface="Calibri" pitchFamily="34" charset="0"/>
                 <a:ea typeface="Calibri" pitchFamily="34" charset="-122"/>
                 <a:cs typeface="Calibri" pitchFamily="34" charset="-120"/>
-                <a:hlinkClick r:id="rId13" invalidUrl="" action="" tgtFrame="" tooltip="https://www.youtube.com/watch?v=NlYjcldubBg" history="1" highlightClick="0" endSnd="0">
+                <a:hlinkClick r:id="rId13" invalidUrl="" action="" tgtFrame="" tooltip="https://algoritmos.uniandes.edu.co/xxv-jornadas-gecti-derecho-tecnologia-y-sociedad-digital/" history="1" highlightClick="0" endSnd="0">
                   <a:extLst>
                     <a:ext uri="{A12FA001-AC4F-418D-AE19-62706E023703}">
                       <ahyp:hlinkClr xmlns:ahyp="http://schemas.microsoft.com/office/drawing/2018/hyperlinkcolor" val="tx"/>
@@ -29222,7 +29345,7 @@
                   </a:extLst>
                 </a:hlinkClick>
               </a:rPr>
-              <a:t>(Deep) Learning From the Bench: A Conversation on Algorithmic Fairness (Berkman Klein Center)</a:t>
+              <a:t>XXV Jornadas GECTI: Derecho, Tecnología y Sociedad Digital (Uniandes, 29 de mayo de 2026; programa)</a:t>
             </a:r>
             <a:endParaRPr lang="en-US" sz="950" dirty="0"/>
           </a:p>
@@ -29261,7 +29384,7 @@
                 <a:ea typeface="Calibri" pitchFamily="34" charset="-122"/>
                 <a:cs typeface="Calibri" pitchFamily="34" charset="-120"/>
               </a:rPr>
-              <a:t>Bloque 4 →</a:t>
+              <a:t>Video 4 →</a:t>
             </a:r>
             <a:endParaRPr lang="en-US" sz="950" dirty="0"/>
           </a:p>
@@ -29304,7 +29427,7 @@
                 <a:latin typeface="Calibri" pitchFamily="34" charset="0"/>
                 <a:ea typeface="Calibri" pitchFamily="34" charset="-122"/>
                 <a:cs typeface="Calibri" pitchFamily="34" charset="-120"/>
-                <a:hlinkClick r:id="rId14" invalidUrl="" action="" tgtFrame="" tooltip="https://www.youtube.com/watch?v=veu2Gt1BqeE" history="1" highlightClick="0" endSnd="0">
+                <a:hlinkClick r:id="rId14" invalidUrl="" action="" tgtFrame="" tooltip="https://www.youtube.com/playlist?list=PL68azUN8PTNg25bFCYPRWnNjILYoOrbtg" history="1" highlightClick="0" endSnd="0">
                   <a:extLst>
                     <a:ext uri="{A12FA001-AC4F-418D-AE19-62706E023703}">
                       <ahyp:hlinkClr xmlns:ahyp="http://schemas.microsoft.com/office/drawing/2018/hyperlinkcolor" val="tx"/>
@@ -29312,7 +29435,7 @@
                   </a:extLst>
                 </a:hlinkClick>
               </a:rPr>
-              <a:t>Retos de la inteligencia artificial en la protección de los derechos humanos (Facultad de Derecho Uniandes, 2025)</a:t>
+              <a:t>AI Governance Speaker Series (Spring 2026), Berkman Klein Center: «Legal Telescopes» (Neel Guha) y conversación con Julie Brill</a:t>
             </a:r>
             <a:endParaRPr lang="en-US" sz="950" dirty="0"/>
           </a:p>
@@ -29375,7 +29498,7 @@
               <a:buNone/>
             </a:pPr>
             <a:r>
-              <a:rPr lang="en-US" sz="2800" b="1" dirty="0">
+              <a:rPr lang="en-US" sz="2400" b="1" dirty="0">
                 <a:solidFill>
                   <a:srgbClr val="1B2A41"/>
                 </a:solidFill>
@@ -29383,9 +29506,9 @@
                 <a:ea typeface="Cambria" pitchFamily="34" charset="-122"/>
                 <a:cs typeface="Cambria" pitchFamily="34" charset="-120"/>
               </a:rPr>
-              <a:t>Video 1 · La IA en el trabajo del abogado</a:t>
-            </a:r>
-            <a:endParaRPr lang="en-US" sz="2800" dirty="0"/>
+              <a:t>Video 1 · Los desafíos del derecho en la era de la IA</a:t>
+            </a:r>
+            <a:endParaRPr lang="en-US" sz="2400" dirty="0"/>
           </a:p>
         </p:txBody>
       </p:sp>
@@ -29642,7 +29765,7 @@
                 <a:ea typeface="Calibri" pitchFamily="34" charset="-122"/>
                 <a:cs typeface="Calibri" pitchFamily="34" charset="-120"/>
               </a:rPr>
-              <a:t>Understanding Impacts of AI on the Legal Profession</a:t>
+              <a:t>Desafíos del derecho en la era de la Inteligencia Artificial</a:t>
             </a:r>
             <a:endParaRPr lang="en-US" sz="1600" dirty="0"/>
           </a:p>
@@ -29681,7 +29804,7 @@
                 <a:ea typeface="Calibri" pitchFamily="34" charset="-122"/>
                 <a:cs typeface="Calibri" pitchFamily="34" charset="-120"/>
               </a:rPr>
-              <a:t>CS50's Computer Science for Lawyers · Harvard</a:t>
+              <a:t>Facultad de Derecho · Universidad de los Andes · 6 de febrero de 2026</a:t>
             </a:r>
             <a:endParaRPr lang="en-US" sz="1150" dirty="0"/>
           </a:p>
@@ -29790,7 +29913,7 @@
                 <a:latin typeface="Calibri" pitchFamily="34" charset="0"/>
                 <a:ea typeface="Calibri" pitchFamily="34" charset="-122"/>
                 <a:cs typeface="Calibri" pitchFamily="34" charset="-120"/>
-                <a:hlinkClick r:id="rId2" invalidUrl="" action="" tgtFrame="" tooltip="https://www.youtube.com/watch?v=Y8UHDl2IJOM" history="1" highlightClick="0" endSnd="0">
+                <a:hlinkClick r:id="rId2" invalidUrl="" action="" tgtFrame="" tooltip="https://www.youtube.com/watch?v=IvcNLzlJUHA" history="1" highlightClick="0" endSnd="0">
                   <a:extLst>
                     <a:ext uri="{A12FA001-AC4F-418D-AE19-62706E023703}">
                       <ahyp:hlinkClr xmlns:ahyp="http://schemas.microsoft.com/office/drawing/2018/hyperlinkcolor" val="tx"/>
@@ -29841,7 +29964,7 @@
                 <a:latin typeface="Calibri" pitchFamily="34" charset="0"/>
                 <a:ea typeface="Calibri" pitchFamily="34" charset="-122"/>
                 <a:cs typeface="Calibri" pitchFamily="34" charset="-120"/>
-                <a:hlinkClick r:id="rId3" invalidUrl="" action="" tgtFrame="" tooltip="https://www.youtube.com/watch?v=Y8UHDl2IJOM" history="1" highlightClick="0" endSnd="0">
+                <a:hlinkClick r:id="rId3" invalidUrl="" action="" tgtFrame="" tooltip="https://www.youtube.com/watch?v=IvcNLzlJUHA" history="1" highlightClick="0" endSnd="0">
                   <a:extLst>
                     <a:ext uri="{A12FA001-AC4F-418D-AE19-62706E023703}">
                       <ahyp:hlinkClr xmlns:ahyp="http://schemas.microsoft.com/office/drawing/2018/hyperlinkcolor" val="tx"/>
@@ -29849,7 +29972,7 @@
                   </a:extLst>
                 </a:hlinkClick>
               </a:rPr>
-              <a:t>https://www.youtube.com/watch?v=Y8UHDl2IJOM</a:t>
+              <a:t>https://www.youtube.com/watch?v=IvcNLzlJUHA</a:t>
             </a:r>
             <a:endParaRPr lang="en-US" sz="950" dirty="0"/>
           </a:p>
@@ -29931,7 +30054,7 @@
                 <a:latin typeface="Calibri" pitchFamily="34" charset="0"/>
                 <a:ea typeface="Calibri" pitchFamily="34" charset="-122"/>
                 <a:cs typeface="Calibri" pitchFamily="34" charset="-120"/>
-                <a:hlinkClick r:id="rId4" invalidUrl="" action="" tgtFrame="" tooltip="https://www.youtube.com/watch?v=IvcNLzlJUHA" history="1" highlightClick="0" endSnd="0">
+                <a:hlinkClick r:id="rId4" invalidUrl="" action="" tgtFrame="" tooltip="https://www.youtube.com/watch?v=veu2Gt1BqeE" history="1" highlightClick="0" endSnd="0">
                   <a:extLst>
                     <a:ext uri="{A12FA001-AC4F-418D-AE19-62706E023703}">
                       <ahyp:hlinkClr xmlns:ahyp="http://schemas.microsoft.com/office/drawing/2018/hyperlinkcolor" val="tx"/>
@@ -29939,7 +30062,7 @@
                   </a:extLst>
                 </a:hlinkClick>
               </a:rPr>
-              <a:t>Desafíos del derecho en la era de la Inteligencia Artificial (Facultad de Derecho Uniandes, 2026)</a:t>
+              <a:t>Retos de la inteligencia artificial en la protección de los derechos humanos (Facultad de Derecho Uniandes, 12 de mayo de 2025)</a:t>
             </a:r>
             <a:endParaRPr lang="en-US" sz="950" dirty="0"/>
           </a:p>

</xml_diff>